<commit_message>
Finalize: EMNIST label-flip complete (36/36); fill last cells, recompile, refresh deck
- Label-flip table now fully populated (FedGT-EMNIST, FLTrust-EMNIST f.3 filled).
- Honest correction: EMNIST label-flip is a near-tie (FedGT edges f.1/.2 by 0.1-0.3,
  CB-SAFE+ leads f.3); deck Generalization line updated from "wins outright".
- Recompiled paper (12 pp) and re-cropped paper tables/figures into the deck.

Co-Authored-By: Claude Opus 4.8 <noreply@anthropic.com>
</commit_message>
<xml_diff>
--- a/paper/cbsafe_deck.pptx
+++ b/paper/cbsafe_deck.pptx
@@ -5695,7 +5695,7 @@
         <p:spPr>
           <a:xfrm>
             <a:off x="7315200" y="1463040"/>
-            <a:ext cx="4480560" cy="4774367"/>
+            <a:ext cx="4480560" cy="4785619"/>
           </a:xfrm>
           <a:prstGeom prst="rect">
             <a:avLst/>
@@ -5942,8 +5942,8 @@
         </p:blipFill>
         <p:spPr>
           <a:xfrm>
-            <a:off x="825017" y="2331720"/>
-            <a:ext cx="10541659" cy="3246120"/>
+            <a:off x="831602" y="2331720"/>
+            <a:ext cx="10528491" cy="3246120"/>
           </a:xfrm>
           <a:prstGeom prst="rect">
             <a:avLst/>
@@ -6658,7 +6658,7 @@
                 </a:solidFill>
                 <a:latin typeface="Segoe UI"/>
               </a:rPr>
-              <a:t>Label-flip test accuracy (from the paper, Table VI); CB-SAFE+ wins EMNIST outright.</a:t>
+              <a:t>Label-flip test accuracy (from the paper, Table VI); CB-SAFE+ matches FedGT and leads at the hardest setting (f=0.3).</a:t>
             </a:r>
           </a:p>
         </p:txBody>
@@ -6727,8 +6727,8 @@
         </p:blipFill>
         <p:spPr>
           <a:xfrm>
-            <a:off x="1122770" y="2331720"/>
-            <a:ext cx="9946153" cy="3200400"/>
+            <a:off x="1082746" y="2331720"/>
+            <a:ext cx="10026203" cy="3200400"/>
           </a:xfrm>
           <a:prstGeom prst="rect">
             <a:avLst/>

</xml_diff>

<commit_message>
Deck: add 9-panel training-dynamics figure, black citations, Calibri font
- New "Results: Training Dynamics" slide with the 3x3 (dataset x f) accuracy-vs-round
  figure cropped from the paper (Fig. 7); deck now 23 numbered content slides.
- Citation footnotes recolored from blue to near-black.
- Body font switched to Calibri throughout.

Co-Authored-By: Claude Opus 4.8 <noreply@anthropic.com>
</commit_message>
<xml_diff>
--- a/paper/cbsafe_deck.pptx
+++ b/paper/cbsafe_deck.pptx
@@ -29,6 +29,7 @@
     <p:sldId id="277" r:id="rId28"/>
     <p:sldId id="278" r:id="rId29"/>
     <p:sldId id="279" r:id="rId30"/>
+    <p:sldId id="280" r:id="rId31"/>
   </p:sldIdLst>
   <p:sldSz cx="12191695" cy="6858000" type="screen4x3"/>
   <p:notesSz cx="6858000" cy="9144000"/>
@@ -3138,7 +3139,7 @@
                 <a:solidFill>
                   <a:srgbClr val="2A78D6"/>
                 </a:solidFill>
-                <a:latin typeface="Segoe UI"/>
+                <a:latin typeface="Calibri"/>
               </a:rPr>
               <a:t>POST-QUANTUM CRYPTOGRAPHY × FEDERATED LEARNING</a:t>
             </a:r>
@@ -3172,7 +3173,7 @@
                 <a:solidFill>
                   <a:srgbClr val="0B0B0B"/>
                 </a:solidFill>
-                <a:latin typeface="Segoe UI"/>
+                <a:latin typeface="Calibri"/>
               </a:rPr>
               <a:t>CB-SAFE: Code-Based Post-Quantum Secure Aggregation for Byzantine-Robust Federated Learning</a:t>
             </a:r>
@@ -3206,7 +3207,7 @@
                 <a:solidFill>
                   <a:srgbClr val="26251F"/>
                 </a:solidFill>
-                <a:latin typeface="Segoe UI"/>
+                <a:latin typeface="Calibri"/>
               </a:rPr>
               <a:t>Md Wahiduzzaman Suva (26-94088-2)   ·   Esm-e Moula Chowdhury Abha (26-94089-2)</a:t>
             </a:r>
@@ -3240,7 +3241,7 @@
                 <a:solidFill>
                   <a:srgbClr val="898781"/>
                 </a:solidFill>
-                <a:latin typeface="Segoe UI"/>
+                <a:latin typeface="Calibri"/>
               </a:rPr>
               <a:t>Department of Computer Science, American International University–Bangladesh</a:t>
             </a:r>
@@ -3274,9 +3275,9 @@
                 <a:solidFill>
                   <a:srgbClr val="898781"/>
                 </a:solidFill>
-                <a:latin typeface="Segoe UI"/>
-              </a:rPr>
-              <a:t>Slides 1–15: required method presentation.   Slides 16–22: full-paper research walkthrough.</a:t>
+                <a:latin typeface="Calibri"/>
+              </a:rPr>
+              <a:t>Slides 1–15: required method presentation.   Slides 16–23: full-paper research walkthrough.</a:t>
             </a:r>
           </a:p>
         </p:txBody>
@@ -3326,7 +3327,7 @@
                 <a:solidFill>
                   <a:srgbClr val="0B0B0B"/>
                 </a:solidFill>
-                <a:latin typeface="Segoe UI"/>
+                <a:latin typeface="Calibri"/>
               </a:rPr>
               <a:t>Methodology (Ours): Detection</a:t>
             </a:r>
@@ -3365,7 +3366,7 @@
                 <a:solidFill>
                   <a:srgbClr val="2A78D6"/>
                 </a:solidFill>
-                <a:latin typeface="Segoe UI"/>
+                <a:latin typeface="Calibri"/>
               </a:rPr>
               <a:t>▪  </a:t>
             </a:r>
@@ -3374,7 +3375,7 @@
                 <a:solidFill>
                   <a:srgbClr val="26251F"/>
                 </a:solidFill>
-                <a:latin typeface="Segoe UI"/>
+                <a:latin typeface="Calibri"/>
               </a:rPr>
               <a:t>We adopt the core idea: identify malicious clients from group-level observations, never from individual updates.</a:t>
             </a:r>
@@ -3390,7 +3391,7 @@
                 <a:solidFill>
                   <a:srgbClr val="2A78D6"/>
                 </a:solidFill>
-                <a:latin typeface="Segoe UI"/>
+                <a:latin typeface="Calibri"/>
               </a:rPr>
               <a:t>▪  </a:t>
             </a:r>
@@ -3399,7 +3400,7 @@
                 <a:solidFill>
                   <a:srgbClr val="26251F"/>
                 </a:solidFill>
-                <a:latin typeface="Segoe UI"/>
+                <a:latin typeface="Calibri"/>
               </a:rPr>
               <a:t>The groups are the privacy-preserving cluster sums (the pools); a probe flags contaminated pools.</a:t>
             </a:r>
@@ -3415,7 +3416,7 @@
                 <a:solidFill>
                   <a:srgbClr val="2A78D6"/>
                 </a:solidFill>
-                <a:latin typeface="Segoe UI"/>
+                <a:latin typeface="Calibri"/>
               </a:rPr>
               <a:t>▪  </a:t>
             </a:r>
@@ -3424,7 +3425,7 @@
                 <a:solidFill>
                   <a:srgbClr val="26251F"/>
                 </a:solidFill>
-                <a:latin typeface="Segoe UI"/>
+                <a:latin typeface="Calibri"/>
               </a:rPr>
               <a:t>Our change: tests repeat over re-randomized clusters and accumulate across rounds (temporal group testing).</a:t>
             </a:r>
@@ -3461,9 +3462,9 @@
             <a:r>
               <a:rPr sz="800" b="0" i="1">
                 <a:solidFill>
-                  <a:srgbClr val="2A78D6"/>
-                </a:solidFill>
-                <a:latin typeface="Segoe UI"/>
+                  <a:srgbClr val="26251F"/>
+                </a:solidFill>
+                <a:latin typeface="Calibri"/>
               </a:rPr>
               <a:t>[1] M. Xhemrishi, J. Östman, A. Wachter-Zeh, and A. Graell i Amat, "FedGT: Identification of malicious clients in federated learning with secure aggregation," IEEE Trans. Inf. Forensics Security, vol. 20, pp. 2577–2592, 2025.</a:t>
             </a:r>
@@ -3498,9 +3499,9 @@
                 <a:solidFill>
                   <a:srgbClr val="898781"/>
                 </a:solidFill>
-                <a:latin typeface="Segoe UI"/>
-              </a:rPr>
-              <a:t>9 / 22</a:t>
+                <a:latin typeface="Calibri"/>
+              </a:rPr>
+              <a:t>9 / 23</a:t>
             </a:r>
           </a:p>
         </p:txBody>
@@ -3550,7 +3551,7 @@
                 <a:solidFill>
                   <a:srgbClr val="0B0B0B"/>
                 </a:solidFill>
-                <a:latin typeface="Segoe UI"/>
+                <a:latin typeface="Calibri"/>
               </a:rPr>
               <a:t>Methodology (Ours): Cryptography</a:t>
             </a:r>
@@ -3589,7 +3590,7 @@
                 <a:solidFill>
                   <a:srgbClr val="2A78D6"/>
                 </a:solidFill>
-                <a:latin typeface="Segoe UI"/>
+                <a:latin typeface="Calibri"/>
               </a:rPr>
               <a:t>▪  </a:t>
             </a:r>
@@ -3598,7 +3599,7 @@
                 <a:solidFill>
                   <a:srgbClr val="26251F"/>
                 </a:solidFill>
-                <a:latin typeface="Segoe UI"/>
+                <a:latin typeface="Calibri"/>
               </a:rPr>
               <a:t>We adopt HQC, the code-based KEM NIST selected in 2025, for post-quantum confidentiality.</a:t>
             </a:r>
@@ -3614,7 +3615,7 @@
                 <a:solidFill>
                   <a:srgbClr val="2A78D6"/>
                 </a:solidFill>
-                <a:latin typeface="Segoe UI"/>
+                <a:latin typeface="Calibri"/>
               </a:rPr>
               <a:t>▪  </a:t>
             </a:r>
@@ -3623,7 +3624,7 @@
                 <a:solidFill>
                   <a:srgbClr val="26251F"/>
                 </a:solidFill>
-                <a:latin typeface="Segoe UI"/>
+                <a:latin typeface="Calibri"/>
               </a:rPr>
               <a:t>Its security rests on syndrome decoding of quasi-cyclic codes, not lattices: genuine cryptographic diversity.</a:t>
             </a:r>
@@ -3639,7 +3640,7 @@
                 <a:solidFill>
                   <a:srgbClr val="2A78D6"/>
                 </a:solidFill>
-                <a:latin typeface="Segoe UI"/>
+                <a:latin typeface="Calibri"/>
               </a:rPr>
               <a:t>▪  </a:t>
             </a:r>
@@ -3648,7 +3649,7 @@
                 <a:solidFill>
                   <a:srgbClr val="26251F"/>
                 </a:solidFill>
-                <a:latin typeface="Segoe UI"/>
+                <a:latin typeface="Calibri"/>
               </a:rPr>
               <a:t>Our change: HQC sits behind a KEM-agnostic interface, so ML-KEM swaps in with one configuration line.</a:t>
             </a:r>
@@ -3685,9 +3686,9 @@
             <a:r>
               <a:rPr sz="800" b="0" i="1">
                 <a:solidFill>
-                  <a:srgbClr val="2A78D6"/>
-                </a:solidFill>
-                <a:latin typeface="Segoe UI"/>
+                  <a:srgbClr val="26251F"/>
+                </a:solidFill>
+                <a:latin typeface="Calibri"/>
               </a:rPr>
               <a:t>[3] National Institute of Standards and Technology, "Status report on the fourth round of the NIST post-quantum cryptography standardization process," NIST IR 8545, Mar. 2025.</a:t>
             </a:r>
@@ -3701,9 +3702,9 @@
             <a:r>
               <a:rPr sz="800" b="0" i="1">
                 <a:solidFill>
-                  <a:srgbClr val="2A78D6"/>
-                </a:solidFill>
-                <a:latin typeface="Segoe UI"/>
+                  <a:srgbClr val="26251F"/>
+                </a:solidFill>
+                <a:latin typeface="Calibri"/>
               </a:rPr>
               <a:t>[9] National Institute of Standards and Technology, "Module-lattice-based key-encapsulation mechanism standard," FIPS 203, Aug. 2024.</a:t>
             </a:r>
@@ -3738,9 +3739,9 @@
                 <a:solidFill>
                   <a:srgbClr val="898781"/>
                 </a:solidFill>
-                <a:latin typeface="Segoe UI"/>
-              </a:rPr>
-              <a:t>10 / 22</a:t>
+                <a:latin typeface="Calibri"/>
+              </a:rPr>
+              <a:t>10 / 23</a:t>
             </a:r>
           </a:p>
         </p:txBody>
@@ -3790,7 +3791,7 @@
                 <a:solidFill>
                   <a:srgbClr val="0B0B0B"/>
                 </a:solidFill>
-                <a:latin typeface="Segoe UI"/>
+                <a:latin typeface="Calibri"/>
               </a:rPr>
               <a:t>Methodology (Ours): Integration</a:t>
             </a:r>
@@ -3824,7 +3825,7 @@
                 <a:solidFill>
                   <a:srgbClr val="26251F"/>
                 </a:solidFill>
-                <a:latin typeface="Segoe UI"/>
+                <a:latin typeface="Calibri"/>
               </a:rPr>
               <a:t>Masking + group testing + a code-based KEM become one coherent framework.</a:t>
             </a:r>
@@ -3863,7 +3864,7 @@
                 <a:solidFill>
                   <a:srgbClr val="2A78D6"/>
                 </a:solidFill>
-                <a:latin typeface="Segoe UI"/>
+                <a:latin typeface="Calibri"/>
               </a:rPr>
               <a:t>▪  </a:t>
             </a:r>
@@ -3872,7 +3873,7 @@
                 <a:solidFill>
                   <a:srgbClr val="26251F"/>
                 </a:solidFill>
-                <a:latin typeface="Segoe UI"/>
+                <a:latin typeface="Calibri"/>
               </a:rPr>
               <a:t>HQC-seeded masking [2], [3] hides updates inside clusters, so the server sees only cluster sums.</a:t>
             </a:r>
@@ -3888,7 +3889,7 @@
                 <a:solidFill>
                   <a:srgbClr val="2A78D6"/>
                 </a:solidFill>
-                <a:latin typeface="Segoe UI"/>
+                <a:latin typeface="Calibri"/>
               </a:rPr>
               <a:t>▪  </a:t>
             </a:r>
@@ -3897,7 +3898,7 @@
                 <a:solidFill>
                   <a:srgbClr val="26251F"/>
                 </a:solidFill>
-                <a:latin typeface="Segoe UI"/>
+                <a:latin typeface="Calibri"/>
               </a:rPr>
               <a:t>Group testing [1] then runs across those cluster sums, over re-randomized rounds, to name the attackers.</a:t>
             </a:r>
@@ -3913,7 +3914,7 @@
                 <a:solidFill>
                   <a:srgbClr val="2A78D6"/>
                 </a:solidFill>
-                <a:latin typeface="Segoe UI"/>
+                <a:latin typeface="Calibri"/>
               </a:rPr>
               <a:t>▪  </a:t>
             </a:r>
@@ -3922,7 +3923,7 @@
                 <a:solidFill>
                   <a:srgbClr val="26251F"/>
                 </a:solidFill>
-                <a:latin typeface="Segoe UI"/>
+                <a:latin typeface="Calibri"/>
               </a:rPr>
               <a:t>Net design: privacy below the cluster boundary, robustness above it, code-based crypto throughout.</a:t>
             </a:r>
@@ -3938,7 +3939,7 @@
                 <a:solidFill>
                   <a:srgbClr val="2A78D6"/>
                 </a:solidFill>
-                <a:latin typeface="Segoe UI"/>
+                <a:latin typeface="Calibri"/>
               </a:rPr>
               <a:t>▪  </a:t>
             </a:r>
@@ -3947,7 +3948,7 @@
                 <a:solidFill>
                   <a:srgbClr val="26251F"/>
                 </a:solidFill>
-                <a:latin typeface="Segoe UI"/>
+                <a:latin typeface="Calibri"/>
               </a:rPr>
               <a:t>On top we add our own pieces: the laundering theorem and a server root-loss probe.</a:t>
             </a:r>
@@ -3984,9 +3985,9 @@
             <a:r>
               <a:rPr sz="800" b="0" i="1">
                 <a:solidFill>
-                  <a:srgbClr val="2A78D6"/>
-                </a:solidFill>
-                <a:latin typeface="Segoe UI"/>
+                  <a:srgbClr val="26251F"/>
+                </a:solidFill>
+                <a:latin typeface="Calibri"/>
               </a:rPr>
               <a:t>[1] M. Xhemrishi, J. Östman, A. Wachter-Zeh, and A. Graell i Amat, "FedGT: Identification of malicious clients in federated learning with secure aggregation," IEEE Trans. Inf. Forensics Security, vol. 20, pp. 2577–2592, 2025.</a:t>
             </a:r>
@@ -4000,9 +4001,9 @@
             <a:r>
               <a:rPr sz="800" b="0" i="1">
                 <a:solidFill>
-                  <a:srgbClr val="2A78D6"/>
-                </a:solidFill>
-                <a:latin typeface="Segoe UI"/>
+                  <a:srgbClr val="26251F"/>
+                </a:solidFill>
+                <a:latin typeface="Calibri"/>
               </a:rPr>
               <a:t>[2] K. Bonawitz, V. Ivanov, B. Kreuter, A. Marcedone, H. B. McMahan, S. Patel, D. Ramage, A. Segal, and K. Seth, "Practical secure aggregation for privacy-preserving machine learning," in Proc. ACM CCS, 2017, pp. 1175–1191.</a:t>
             </a:r>
@@ -4037,9 +4038,9 @@
                 <a:solidFill>
                   <a:srgbClr val="898781"/>
                 </a:solidFill>
-                <a:latin typeface="Segoe UI"/>
-              </a:rPr>
-              <a:t>11 / 22</a:t>
+                <a:latin typeface="Calibri"/>
+              </a:rPr>
+              <a:t>11 / 23</a:t>
             </a:r>
           </a:p>
         </p:txBody>
@@ -4089,7 +4090,7 @@
                 <a:solidFill>
                   <a:srgbClr val="0B0B0B"/>
                 </a:solidFill>
-                <a:latin typeface="Segoe UI"/>
+                <a:latin typeface="Calibri"/>
               </a:rPr>
               <a:t>Comparison</a:t>
             </a:r>
@@ -4128,7 +4129,7 @@
                 <a:solidFill>
                   <a:srgbClr val="2A78D6"/>
                 </a:solidFill>
-                <a:latin typeface="Segoe UI"/>
+                <a:latin typeface="Calibri"/>
               </a:rPr>
               <a:t>▪  </a:t>
             </a:r>
@@ -4137,7 +4138,7 @@
                 <a:solidFill>
                   <a:srgbClr val="26251F"/>
                 </a:solidFill>
-                <a:latin typeface="Segoe UI"/>
+                <a:latin typeface="Calibri"/>
               </a:rPr>
               <a:t>Crypto: FedGT is crypto-agnostic → </a:t>
             </a:r>
@@ -4146,7 +4147,7 @@
                 <a:solidFill>
                   <a:srgbClr val="0B0B0B"/>
                 </a:solidFill>
-                <a:latin typeface="Segoe UI"/>
+                <a:latin typeface="Calibri"/>
               </a:rPr>
               <a:t>CB-SAFE is code-based post-quantum</a:t>
             </a:r>
@@ -4155,7 +4156,7 @@
                 <a:solidFill>
                   <a:srgbClr val="26251F"/>
                 </a:solidFill>
-                <a:latin typeface="Segoe UI"/>
+                <a:latin typeface="Calibri"/>
               </a:rPr>
               <a:t>.</a:t>
             </a:r>
@@ -4171,7 +4172,7 @@
                 <a:solidFill>
                   <a:srgbClr val="2A78D6"/>
                 </a:solidFill>
-                <a:latin typeface="Segoe UI"/>
+                <a:latin typeface="Calibri"/>
               </a:rPr>
               <a:t>▪  </a:t>
             </a:r>
@@ -4180,7 +4181,7 @@
                 <a:solidFill>
                   <a:srgbClr val="26251F"/>
                 </a:solidFill>
-                <a:latin typeface="Segoe UI"/>
+                <a:latin typeface="Calibri"/>
               </a:rPr>
               <a:t>Detection: FedGT uses single-round COMP + a validation set → </a:t>
             </a:r>
@@ -4189,7 +4190,7 @@
                 <a:solidFill>
                   <a:srgbClr val="0B0B0B"/>
                 </a:solidFill>
-                <a:latin typeface="Segoe UI"/>
+                <a:latin typeface="Calibri"/>
               </a:rPr>
               <a:t>CB-SAFE uses temporal accumulation + a root-loss probe</a:t>
             </a:r>
@@ -4198,7 +4199,7 @@
                 <a:solidFill>
                   <a:srgbClr val="26251F"/>
                 </a:solidFill>
-                <a:latin typeface="Segoe UI"/>
+                <a:latin typeface="Calibri"/>
               </a:rPr>
               <a:t>.</a:t>
             </a:r>
@@ -4214,7 +4215,7 @@
                 <a:solidFill>
                   <a:srgbClr val="2A78D6"/>
                 </a:solidFill>
-                <a:latin typeface="Segoe UI"/>
+                <a:latin typeface="Calibri"/>
               </a:rPr>
               <a:t>▪  </a:t>
             </a:r>
@@ -4223,7 +4224,7 @@
                 <a:solidFill>
                   <a:srgbClr val="26251F"/>
                 </a:solidFill>
-                <a:latin typeface="Segoe UI"/>
+                <a:latin typeface="Calibri"/>
               </a:rPr>
               <a:t>Theory: FedGT gives no failure model → </a:t>
             </a:r>
@@ -4232,7 +4233,7 @@
                 <a:solidFill>
                   <a:srgbClr val="0B0B0B"/>
                 </a:solidFill>
-                <a:latin typeface="Segoe UI"/>
+                <a:latin typeface="Calibri"/>
               </a:rPr>
               <a:t>CB-SAFE proves the laundering boundary</a:t>
             </a:r>
@@ -4241,7 +4242,7 @@
                 <a:solidFill>
                   <a:srgbClr val="26251F"/>
                 </a:solidFill>
-                <a:latin typeface="Segoe UI"/>
+                <a:latin typeface="Calibri"/>
               </a:rPr>
               <a:t>.</a:t>
             </a:r>
@@ -4257,7 +4258,7 @@
                 <a:solidFill>
                   <a:srgbClr val="2A78D6"/>
                 </a:solidFill>
-                <a:latin typeface="Segoe UI"/>
+                <a:latin typeface="Calibri"/>
               </a:rPr>
               <a:t>▪  </a:t>
             </a:r>
@@ -4266,7 +4267,7 @@
                 <a:solidFill>
                   <a:srgbClr val="26251F"/>
                 </a:solidFill>
-                <a:latin typeface="Segoe UI"/>
+                <a:latin typeface="Calibri"/>
               </a:rPr>
               <a:t>Results: accuracy ties FedGT with </a:t>
             </a:r>
@@ -4275,7 +4276,7 @@
                 <a:solidFill>
                   <a:srgbClr val="0B0B0B"/>
                 </a:solidFill>
-                <a:latin typeface="Segoe UI"/>
+                <a:latin typeface="Calibri"/>
               </a:rPr>
               <a:t>fewer false exclusions and ~4× lower cost</a:t>
             </a:r>
@@ -4284,7 +4285,7 @@
                 <a:solidFill>
                   <a:srgbClr val="26251F"/>
                 </a:solidFill>
-                <a:latin typeface="Segoe UI"/>
+                <a:latin typeface="Calibri"/>
               </a:rPr>
               <a:t>.</a:t>
             </a:r>
@@ -4345,9 +4346,9 @@
             <a:r>
               <a:rPr sz="800" b="0" i="1">
                 <a:solidFill>
-                  <a:srgbClr val="2A78D6"/>
-                </a:solidFill>
-                <a:latin typeface="Segoe UI"/>
+                  <a:srgbClr val="26251F"/>
+                </a:solidFill>
+                <a:latin typeface="Calibri"/>
               </a:rPr>
               <a:t>[1] M. Xhemrishi, J. Östman, A. Wachter-Zeh, and A. Graell i Amat, "FedGT: Identification of malicious clients in federated learning with secure aggregation," IEEE Trans. Inf. Forensics Security, vol. 20, pp. 2577–2592, 2025.</a:t>
             </a:r>
@@ -4382,9 +4383,9 @@
                 <a:solidFill>
                   <a:srgbClr val="898781"/>
                 </a:solidFill>
-                <a:latin typeface="Segoe UI"/>
-              </a:rPr>
-              <a:t>12 / 22</a:t>
+                <a:latin typeface="Calibri"/>
+              </a:rPr>
+              <a:t>12 / 23</a:t>
             </a:r>
           </a:p>
         </p:txBody>
@@ -4434,7 +4435,7 @@
                 <a:solidFill>
                   <a:srgbClr val="0B0B0B"/>
                 </a:solidFill>
-                <a:latin typeface="Segoe UI"/>
+                <a:latin typeface="Calibri"/>
               </a:rPr>
               <a:t>Contributions</a:t>
             </a:r>
@@ -4473,7 +4474,7 @@
                 <a:solidFill>
                   <a:srgbClr val="2A78D6"/>
                 </a:solidFill>
-                <a:latin typeface="Segoe UI"/>
+                <a:latin typeface="Calibri"/>
               </a:rPr>
               <a:t>▪  </a:t>
             </a:r>
@@ -4482,7 +4483,7 @@
                 <a:solidFill>
                   <a:srgbClr val="0B0B0B"/>
                 </a:solidFill>
-                <a:latin typeface="Segoe UI"/>
+                <a:latin typeface="Calibri"/>
               </a:rPr>
               <a:t>First code-based post-quantum secure aggregation</a:t>
             </a:r>
@@ -4491,7 +4492,7 @@
                 <a:solidFill>
                   <a:srgbClr val="26251F"/>
                 </a:solidFill>
-                <a:latin typeface="Segoe UI"/>
+                <a:latin typeface="Calibri"/>
               </a:rPr>
               <a:t> for FL: cryptographic diversity beyond lattices.</a:t>
             </a:r>
@@ -4507,7 +4508,7 @@
                 <a:solidFill>
                   <a:srgbClr val="2A78D6"/>
                 </a:solidFill>
-                <a:latin typeface="Segoe UI"/>
+                <a:latin typeface="Calibri"/>
               </a:rPr>
               <a:t>▪  </a:t>
             </a:r>
@@ -4516,7 +4517,7 @@
                 <a:solidFill>
                   <a:srgbClr val="26251F"/>
                 </a:solidFill>
-                <a:latin typeface="Segoe UI"/>
+                <a:latin typeface="Calibri"/>
               </a:rPr>
               <a:t>The </a:t>
             </a:r>
@@ -4525,7 +4526,7 @@
                 <a:solidFill>
                   <a:srgbClr val="0B0B0B"/>
                 </a:solidFill>
-                <a:latin typeface="Segoe UI"/>
+                <a:latin typeface="Calibri"/>
               </a:rPr>
               <a:t>laundering theorem</a:t>
             </a:r>
@@ -4534,7 +4535,7 @@
                 <a:solidFill>
                   <a:srgbClr val="26251F"/>
                 </a:solidFill>
-                <a:latin typeface="Segoe UI"/>
+                <a:latin typeface="Calibri"/>
               </a:rPr>
               <a:t>: at γ*=2c/m−1 a poisoned cluster mean is magnitude-invisible, explaining why robust rules fail.</a:t>
             </a:r>
@@ -4550,7 +4551,7 @@
                 <a:solidFill>
                   <a:srgbClr val="2A78D6"/>
                 </a:solidFill>
-                <a:latin typeface="Segoe UI"/>
+                <a:latin typeface="Calibri"/>
               </a:rPr>
               <a:t>▪  </a:t>
             </a:r>
@@ -4559,7 +4560,7 @@
                 <a:solidFill>
                   <a:srgbClr val="0B0B0B"/>
                 </a:solidFill>
-                <a:latin typeface="Segoe UI"/>
+                <a:latin typeface="Calibri"/>
               </a:rPr>
               <a:t>Temporal group testing</a:t>
             </a:r>
@@ -4568,7 +4569,7 @@
                 <a:solidFill>
                   <a:srgbClr val="26251F"/>
                 </a:solidFill>
-                <a:latin typeface="Segoe UI"/>
+                <a:latin typeface="Calibri"/>
               </a:rPr>
               <a:t> over re-randomized clusters with a root-loss probe: identifies attackers the server never sees.</a:t>
             </a:r>
@@ -4584,7 +4585,7 @@
                 <a:solidFill>
                   <a:srgbClr val="2A78D6"/>
                 </a:solidFill>
-                <a:latin typeface="Segoe UI"/>
+                <a:latin typeface="Calibri"/>
               </a:rPr>
               <a:t>▪  </a:t>
             </a:r>
@@ -4593,7 +4594,7 @@
                 <a:solidFill>
                   <a:srgbClr val="26251F"/>
                 </a:solidFill>
-                <a:latin typeface="Segoe UI"/>
+                <a:latin typeface="Calibri"/>
               </a:rPr>
               <a:t>A </a:t>
             </a:r>
@@ -4602,7 +4603,7 @@
                 <a:solidFill>
                   <a:srgbClr val="0B0B0B"/>
                 </a:solidFill>
-                <a:latin typeface="Segoe UI"/>
+                <a:latin typeface="Calibri"/>
               </a:rPr>
               <a:t>trust-free variant</a:t>
             </a:r>
@@ -4611,7 +4612,7 @@
                 <a:solidFill>
                   <a:srgbClr val="26251F"/>
                 </a:solidFill>
-                <a:latin typeface="Segoe UI"/>
+                <a:latin typeface="Calibri"/>
               </a:rPr>
               <a:t> that needs no root dataset, a capability FedGT does not offer.</a:t>
             </a:r>
@@ -4672,9 +4673,9 @@
             <a:r>
               <a:rPr sz="800" b="0" i="1">
                 <a:solidFill>
-                  <a:srgbClr val="2A78D6"/>
-                </a:solidFill>
-                <a:latin typeface="Segoe UI"/>
+                  <a:srgbClr val="26251F"/>
+                </a:solidFill>
+                <a:latin typeface="Calibri"/>
               </a:rPr>
               <a:t>[1] M. Xhemrishi, J. Östman, A. Wachter-Zeh, and A. Graell i Amat, "FedGT: Identification of malicious clients in federated learning with secure aggregation," IEEE Trans. Inf. Forensics Security, vol. 20, pp. 2577–2592, 2025.</a:t>
             </a:r>
@@ -4688,9 +4689,9 @@
             <a:r>
               <a:rPr sz="800" b="0" i="1">
                 <a:solidFill>
-                  <a:srgbClr val="2A78D6"/>
-                </a:solidFill>
-                <a:latin typeface="Segoe UI"/>
+                  <a:srgbClr val="26251F"/>
+                </a:solidFill>
+                <a:latin typeface="Calibri"/>
               </a:rPr>
               <a:t>[5] X. Cao, M. Fang, J. Liu, and N. Z. Gong, "FLTrust: Byzantine-robust federated learning via trust bootstrapping," in Proc. NDSS, 2021.</a:t>
             </a:r>
@@ -4725,9 +4726,9 @@
                 <a:solidFill>
                   <a:srgbClr val="898781"/>
                 </a:solidFill>
-                <a:latin typeface="Segoe UI"/>
-              </a:rPr>
-              <a:t>13 / 22</a:t>
+                <a:latin typeface="Calibri"/>
+              </a:rPr>
+              <a:t>13 / 23</a:t>
             </a:r>
           </a:p>
         </p:txBody>
@@ -4777,7 +4778,7 @@
                 <a:solidFill>
                   <a:srgbClr val="0B0B0B"/>
                 </a:solidFill>
-                <a:latin typeface="Segoe UI"/>
+                <a:latin typeface="Calibri"/>
               </a:rPr>
               <a:t>Selection Criteria</a:t>
             </a:r>
@@ -4816,7 +4817,7 @@
                 <a:solidFill>
                   <a:srgbClr val="2A78D6"/>
                 </a:solidFill>
-                <a:latin typeface="Segoe UI"/>
+                <a:latin typeface="Calibri"/>
               </a:rPr>
               <a:t>▪  </a:t>
             </a:r>
@@ -4825,7 +4826,7 @@
                 <a:solidFill>
                   <a:srgbClr val="26251F"/>
                 </a:solidFill>
-                <a:latin typeface="Segoe UI"/>
+                <a:latin typeface="Calibri"/>
               </a:rPr>
               <a:t>Venue and recency: the basis paper is Q1 (IEEE TIFS), 2025; supporting sources are top-tier (ACM CCS, NIST).</a:t>
             </a:r>
@@ -4841,7 +4842,7 @@
                 <a:solidFill>
                   <a:srgbClr val="2A78D6"/>
                 </a:solidFill>
-                <a:latin typeface="Segoe UI"/>
+                <a:latin typeface="Calibri"/>
               </a:rPr>
               <a:t>▪  </a:t>
             </a:r>
@@ -4850,7 +4851,7 @@
                 <a:solidFill>
                   <a:srgbClr val="26251F"/>
                 </a:solidFill>
-                <a:latin typeface="Segoe UI"/>
+                <a:latin typeface="Calibri"/>
               </a:rPr>
               <a:t>Relevance: every borrowed idea maps directly onto a component of our exact problem.</a:t>
             </a:r>
@@ -4866,7 +4867,7 @@
                 <a:solidFill>
                   <a:srgbClr val="2A78D6"/>
                 </a:solidFill>
-                <a:latin typeface="Segoe UI"/>
+                <a:latin typeface="Calibri"/>
               </a:rPr>
               <a:t>▪  </a:t>
             </a:r>
@@ -4875,7 +4876,7 @@
                 <a:solidFill>
                   <a:srgbClr val="26251F"/>
                 </a:solidFill>
-                <a:latin typeface="Segoe UI"/>
+                <a:latin typeface="Calibri"/>
               </a:rPr>
               <a:t>Method strength: we match SOTA (FedGT) on robustness at ~4× lower cost, add PQC, and prove the failure mechanism.</a:t>
             </a:r>
@@ -4891,7 +4892,7 @@
                 <a:solidFill>
                   <a:srgbClr val="2A78D6"/>
                 </a:solidFill>
-                <a:latin typeface="Segoe UI"/>
+                <a:latin typeface="Calibri"/>
               </a:rPr>
               <a:t>▪  </a:t>
             </a:r>
@@ -4900,7 +4901,7 @@
                 <a:solidFill>
                   <a:srgbClr val="26251F"/>
                 </a:solidFill>
-                <a:latin typeface="Segoe UI"/>
+                <a:latin typeface="Calibri"/>
               </a:rPr>
               <a:t>Breadth and rigor: validated on four datasets and two modalities, multiple seeds, with significance testing.</a:t>
             </a:r>
@@ -4937,9 +4938,9 @@
             <a:r>
               <a:rPr sz="800" b="0" i="1">
                 <a:solidFill>
-                  <a:srgbClr val="2A78D6"/>
-                </a:solidFill>
-                <a:latin typeface="Segoe UI"/>
+                  <a:srgbClr val="26251F"/>
+                </a:solidFill>
+                <a:latin typeface="Calibri"/>
               </a:rPr>
               <a:t>[1] M. Xhemrishi, J. Östman, A. Wachter-Zeh, and A. Graell i Amat, "FedGT: Identification of malicious clients in federated learning with secure aggregation," IEEE Trans. Inf. Forensics Security, vol. 20, pp. 2577–2592, 2025.</a:t>
             </a:r>
@@ -4953,9 +4954,9 @@
             <a:r>
               <a:rPr sz="800" b="0" i="1">
                 <a:solidFill>
-                  <a:srgbClr val="2A78D6"/>
-                </a:solidFill>
-                <a:latin typeface="Segoe UI"/>
+                  <a:srgbClr val="26251F"/>
+                </a:solidFill>
+                <a:latin typeface="Calibri"/>
               </a:rPr>
               <a:t>[2] K. Bonawitz, V. Ivanov, B. Kreuter, A. Marcedone, H. B. McMahan, S. Patel, D. Ramage, A. Segal, and K. Seth, "Practical secure aggregation for privacy-preserving machine learning," in Proc. ACM CCS, 2017, pp. 1175–1191.</a:t>
             </a:r>
@@ -4969,9 +4970,9 @@
             <a:r>
               <a:rPr sz="800" b="0" i="1">
                 <a:solidFill>
-                  <a:srgbClr val="2A78D6"/>
-                </a:solidFill>
-                <a:latin typeface="Segoe UI"/>
+                  <a:srgbClr val="26251F"/>
+                </a:solidFill>
+                <a:latin typeface="Calibri"/>
               </a:rPr>
               <a:t>[3] National Institute of Standards and Technology, "Status report on the fourth round of the NIST post-quantum cryptography standardization process," NIST IR 8545, Mar. 2025.</a:t>
             </a:r>
@@ -5006,9 +5007,9 @@
                 <a:solidFill>
                   <a:srgbClr val="898781"/>
                 </a:solidFill>
-                <a:latin typeface="Segoe UI"/>
-              </a:rPr>
-              <a:t>14 / 22</a:t>
+                <a:latin typeface="Calibri"/>
+              </a:rPr>
+              <a:t>14 / 23</a:t>
             </a:r>
           </a:p>
         </p:txBody>
@@ -5058,7 +5059,7 @@
                 <a:solidFill>
                   <a:srgbClr val="0B0B0B"/>
                 </a:solidFill>
-                <a:latin typeface="Segoe UI"/>
+                <a:latin typeface="Calibri"/>
               </a:rPr>
               <a:t>Summary</a:t>
             </a:r>
@@ -5092,7 +5093,7 @@
                 <a:solidFill>
                   <a:srgbClr val="26251F"/>
                 </a:solidFill>
-                <a:latin typeface="Segoe UI"/>
+                <a:latin typeface="Calibri"/>
               </a:rPr>
               <a:t>End of the required method presentation. Slides 16–22 present the full paper and results.</a:t>
             </a:r>
@@ -5131,7 +5132,7 @@
                 <a:solidFill>
                   <a:srgbClr val="2A78D6"/>
                 </a:solidFill>
-                <a:latin typeface="Segoe UI"/>
+                <a:latin typeface="Calibri"/>
               </a:rPr>
               <a:t>▪  </a:t>
             </a:r>
@@ -5140,7 +5141,7 @@
                 <a:solidFill>
                   <a:srgbClr val="26251F"/>
                 </a:solidFill>
-                <a:latin typeface="Segoe UI"/>
+                <a:latin typeface="Calibri"/>
               </a:rPr>
               <a:t>Took: masking [2], group testing [1], and a code-based KEM [3].</a:t>
             </a:r>
@@ -5156,7 +5157,7 @@
                 <a:solidFill>
                   <a:srgbClr val="2A78D6"/>
                 </a:solidFill>
-                <a:latin typeface="Segoe UI"/>
+                <a:latin typeface="Calibri"/>
               </a:rPr>
               <a:t>▪  </a:t>
             </a:r>
@@ -5165,7 +5166,7 @@
                 <a:solidFill>
                   <a:srgbClr val="26251F"/>
                 </a:solidFill>
-                <a:latin typeface="Segoe UI"/>
+                <a:latin typeface="Calibri"/>
               </a:rPr>
               <a:t>Changed: temporal group testing over re-randomized clusters; HQC-seeded, KEM-agnostic masking.</a:t>
             </a:r>
@@ -5181,7 +5182,7 @@
                 <a:solidFill>
                   <a:srgbClr val="2A78D6"/>
                 </a:solidFill>
-                <a:latin typeface="Segoe UI"/>
+                <a:latin typeface="Calibri"/>
               </a:rPr>
               <a:t>▪  </a:t>
             </a:r>
@@ -5190,7 +5191,7 @@
                 <a:solidFill>
                   <a:srgbClr val="26251F"/>
                 </a:solidFill>
-                <a:latin typeface="Segoe UI"/>
+                <a:latin typeface="Calibri"/>
               </a:rPr>
               <a:t>New: the laundering theorem, the first code-based PQ secure aggregation, and trust-free detection.</a:t>
             </a:r>
@@ -5206,7 +5207,7 @@
                 <a:solidFill>
                   <a:srgbClr val="2A78D6"/>
                 </a:solidFill>
-                <a:latin typeface="Segoe UI"/>
+                <a:latin typeface="Calibri"/>
               </a:rPr>
               <a:t>▪  </a:t>
             </a:r>
@@ -5215,7 +5216,7 @@
                 <a:solidFill>
                   <a:srgbClr val="26251F"/>
                 </a:solidFill>
-                <a:latin typeface="Segoe UI"/>
+                <a:latin typeface="Calibri"/>
               </a:rPr>
               <a:t>Payoff: private, post-quantum, and Byzantine-robust FL that ties the state of the art at lower cost.</a:t>
             </a:r>
@@ -5252,9 +5253,9 @@
             <a:r>
               <a:rPr sz="800" b="0" i="1">
                 <a:solidFill>
-                  <a:srgbClr val="2A78D6"/>
-                </a:solidFill>
-                <a:latin typeface="Segoe UI"/>
+                  <a:srgbClr val="26251F"/>
+                </a:solidFill>
+                <a:latin typeface="Calibri"/>
               </a:rPr>
               <a:t>[1] M. Xhemrishi, J. Östman, A. Wachter-Zeh, and A. Graell i Amat, "FedGT: Identification of malicious clients in federated learning with secure aggregation," IEEE Trans. Inf. Forensics Security, vol. 20, pp. 2577–2592, 2025.</a:t>
             </a:r>
@@ -5268,9 +5269,9 @@
             <a:r>
               <a:rPr sz="800" b="0" i="1">
                 <a:solidFill>
-                  <a:srgbClr val="2A78D6"/>
-                </a:solidFill>
-                <a:latin typeface="Segoe UI"/>
+                  <a:srgbClr val="26251F"/>
+                </a:solidFill>
+                <a:latin typeface="Calibri"/>
               </a:rPr>
               <a:t>[2] K. Bonawitz, V. Ivanov, B. Kreuter, A. Marcedone, H. B. McMahan, S. Patel, D. Ramage, A. Segal, and K. Seth, "Practical secure aggregation for privacy-preserving machine learning," in Proc. ACM CCS, 2017, pp. 1175–1191.</a:t>
             </a:r>
@@ -5284,9 +5285,9 @@
             <a:r>
               <a:rPr sz="800" b="0" i="1">
                 <a:solidFill>
-                  <a:srgbClr val="2A78D6"/>
-                </a:solidFill>
-                <a:latin typeface="Segoe UI"/>
+                  <a:srgbClr val="26251F"/>
+                </a:solidFill>
+                <a:latin typeface="Calibri"/>
               </a:rPr>
               <a:t>[3] National Institute of Standards and Technology, "Status report on the fourth round of the NIST post-quantum cryptography standardization process," NIST IR 8545, Mar. 2025.</a:t>
             </a:r>
@@ -5321,9 +5322,9 @@
                 <a:solidFill>
                   <a:srgbClr val="898781"/>
                 </a:solidFill>
-                <a:latin typeface="Segoe UI"/>
-              </a:rPr>
-              <a:t>15 / 22</a:t>
+                <a:latin typeface="Calibri"/>
+              </a:rPr>
+              <a:t>15 / 23</a:t>
             </a:r>
           </a:p>
         </p:txBody>
@@ -5373,7 +5374,7 @@
                 <a:solidFill>
                   <a:srgbClr val="0B0B0B"/>
                 </a:solidFill>
-                <a:latin typeface="Segoe UI"/>
+                <a:latin typeface="Calibri"/>
               </a:rPr>
               <a:t>System Architecture</a:t>
             </a:r>
@@ -5407,7 +5408,7 @@
                 <a:solidFill>
                   <a:srgbClr val="26251F"/>
                 </a:solidFill>
-                <a:latin typeface="Segoe UI"/>
+                <a:latin typeface="Calibri"/>
               </a:rPr>
               <a:t>One training round: confidentiality within clusters, temporal group testing over re-randomized clusters, robust aggregation.</a:t>
             </a:r>
@@ -5468,9 +5469,9 @@
             <a:r>
               <a:rPr sz="800" b="0" i="1">
                 <a:solidFill>
-                  <a:srgbClr val="2A78D6"/>
-                </a:solidFill>
-                <a:latin typeface="Segoe UI"/>
+                  <a:srgbClr val="26251F"/>
+                </a:solidFill>
+                <a:latin typeface="Calibri"/>
               </a:rPr>
               <a:t>[1] M. Xhemrishi, J. Östman, A. Wachter-Zeh, and A. Graell i Amat, "FedGT: Identification of malicious clients in federated learning with secure aggregation," IEEE Trans. Inf. Forensics Security, vol. 20, pp. 2577–2592, 2025.</a:t>
             </a:r>
@@ -5484,9 +5485,9 @@
             <a:r>
               <a:rPr sz="800" b="0" i="1">
                 <a:solidFill>
-                  <a:srgbClr val="2A78D6"/>
-                </a:solidFill>
-                <a:latin typeface="Segoe UI"/>
+                  <a:srgbClr val="26251F"/>
+                </a:solidFill>
+                <a:latin typeface="Calibri"/>
               </a:rPr>
               <a:t>[2] K. Bonawitz, V. Ivanov, B. Kreuter, A. Marcedone, H. B. McMahan, S. Patel, D. Ramage, A. Segal, and K. Seth, "Practical secure aggregation for privacy-preserving machine learning," in Proc. ACM CCS, 2017, pp. 1175–1191.</a:t>
             </a:r>
@@ -5521,9 +5522,9 @@
                 <a:solidFill>
                   <a:srgbClr val="898781"/>
                 </a:solidFill>
-                <a:latin typeface="Segoe UI"/>
-              </a:rPr>
-              <a:t>16 / 22</a:t>
+                <a:latin typeface="Calibri"/>
+              </a:rPr>
+              <a:t>16 / 23</a:t>
             </a:r>
           </a:p>
         </p:txBody>
@@ -5573,7 +5574,7 @@
                 <a:solidFill>
                   <a:srgbClr val="0B0B0B"/>
                 </a:solidFill>
-                <a:latin typeface="Segoe UI"/>
+                <a:latin typeface="Calibri"/>
               </a:rPr>
               <a:t>Experimental Setup</a:t>
             </a:r>
@@ -5612,7 +5613,7 @@
                 <a:solidFill>
                   <a:srgbClr val="2A78D6"/>
                 </a:solidFill>
-                <a:latin typeface="Segoe UI"/>
+                <a:latin typeface="Calibri"/>
               </a:rPr>
               <a:t>▪  </a:t>
             </a:r>
@@ -5621,7 +5622,7 @@
                 <a:solidFill>
                   <a:srgbClr val="26251F"/>
                 </a:solidFill>
-                <a:latin typeface="Segoe UI"/>
+                <a:latin typeface="Calibri"/>
               </a:rPr>
               <a:t>Images: CIFAR-10, FashionMNIST, EMNIST-balanced (47 classes). Tabular: Edge-IIoTset (IoT intrusion).</a:t>
             </a:r>
@@ -5637,7 +5638,7 @@
                 <a:solidFill>
                   <a:srgbClr val="2A78D6"/>
                 </a:solidFill>
-                <a:latin typeface="Segoe UI"/>
+                <a:latin typeface="Calibri"/>
               </a:rPr>
               <a:t>▪  </a:t>
             </a:r>
@@ -5646,7 +5647,7 @@
                 <a:solidFill>
                   <a:srgbClr val="26251F"/>
                 </a:solidFill>
-                <a:latin typeface="Segoe UI"/>
+                <a:latin typeface="Calibri"/>
               </a:rPr>
               <a:t>Non-IID split via a Dirichlet(0.5) partition; 30 communication rounds; clusters of size c = 3.</a:t>
             </a:r>
@@ -5662,7 +5663,7 @@
                 <a:solidFill>
                   <a:srgbClr val="2A78D6"/>
                 </a:solidFill>
-                <a:latin typeface="Segoe UI"/>
+                <a:latin typeface="Calibri"/>
               </a:rPr>
               <a:t>▪  </a:t>
             </a:r>
@@ -5671,7 +5672,7 @@
                 <a:solidFill>
                   <a:srgbClr val="26251F"/>
                 </a:solidFill>
-                <a:latin typeface="Segoe UI"/>
+                <a:latin typeface="Calibri"/>
               </a:rPr>
               <a:t>Attacks: sign-flip (laundering), label-flip, backdoor. Baselines: mean, trimmed, median, Krum, Bulyan, RFA, FLTrust, FedGT.</a:t>
             </a:r>
@@ -5732,9 +5733,9 @@
             <a:r>
               <a:rPr sz="800" b="0" i="1">
                 <a:solidFill>
-                  <a:srgbClr val="2A78D6"/>
-                </a:solidFill>
-                <a:latin typeface="Segoe UI"/>
+                  <a:srgbClr val="26251F"/>
+                </a:solidFill>
+                <a:latin typeface="Calibri"/>
               </a:rPr>
               <a:t>[1] M. Xhemrishi, J. Östman, A. Wachter-Zeh, and A. Graell i Amat, "FedGT: Identification of malicious clients in federated learning with secure aggregation," IEEE Trans. Inf. Forensics Security, vol. 20, pp. 2577–2592, 2025.</a:t>
             </a:r>
@@ -5748,9 +5749,9 @@
             <a:r>
               <a:rPr sz="800" b="0" i="1">
                 <a:solidFill>
-                  <a:srgbClr val="2A78D6"/>
-                </a:solidFill>
-                <a:latin typeface="Segoe UI"/>
+                  <a:srgbClr val="26251F"/>
+                </a:solidFill>
+                <a:latin typeface="Calibri"/>
               </a:rPr>
               <a:t>[6] D. Yin, Y. Chen, R. Kannan, and P. Bartlett, "Byzantine-robust distributed learning: Towards optimal statistical rates," in Proc. ICML, 2018, pp. 5650–5659.</a:t>
             </a:r>
@@ -5785,9 +5786,9 @@
                 <a:solidFill>
                   <a:srgbClr val="898781"/>
                 </a:solidFill>
-                <a:latin typeface="Segoe UI"/>
-              </a:rPr>
-              <a:t>17 / 22</a:t>
+                <a:latin typeface="Calibri"/>
+              </a:rPr>
+              <a:t>17 / 23</a:t>
             </a:r>
           </a:p>
         </p:txBody>
@@ -5837,7 +5838,7 @@
                 <a:solidFill>
                   <a:srgbClr val="0B0B0B"/>
                 </a:solidFill>
-                <a:latin typeface="Segoe UI"/>
+                <a:latin typeface="Calibri"/>
               </a:rPr>
               <a:t>Results: Robustness</a:t>
             </a:r>
@@ -5871,7 +5872,7 @@
                 <a:solidFill>
                   <a:srgbClr val="26251F"/>
                 </a:solidFill>
-                <a:latin typeface="Segoe UI"/>
+                <a:latin typeface="Calibri"/>
               </a:rPr>
               <a:t>Sign-flip test accuracy across four datasets (from the paper, Table V).</a:t>
             </a:r>
@@ -5910,7 +5911,7 @@
                 <a:solidFill>
                   <a:srgbClr val="2A78D6"/>
                 </a:solidFill>
-                <a:latin typeface="Segoe UI"/>
+                <a:latin typeface="Calibri"/>
               </a:rPr>
               <a:t>▪  </a:t>
             </a:r>
@@ -5919,7 +5920,7 @@
                 <a:solidFill>
                   <a:srgbClr val="26251F"/>
                 </a:solidFill>
-                <a:latin typeface="Segoe UI"/>
+                <a:latin typeface="Calibri"/>
               </a:rPr>
               <a:t>Under sign-flip at f ≥ 0.2 every coordinate-wise rule collapses to chance; CB-SAFE+ holds and ties FedGT.</a:t>
             </a:r>
@@ -5980,9 +5981,9 @@
             <a:r>
               <a:rPr sz="800" b="0" i="1">
                 <a:solidFill>
-                  <a:srgbClr val="2A78D6"/>
-                </a:solidFill>
-                <a:latin typeface="Segoe UI"/>
+                  <a:srgbClr val="26251F"/>
+                </a:solidFill>
+                <a:latin typeface="Calibri"/>
               </a:rPr>
               <a:t>[1] M. Xhemrishi, J. Östman, A. Wachter-Zeh, and A. Graell i Amat, "FedGT: Identification of malicious clients in federated learning with secure aggregation," IEEE Trans. Inf. Forensics Security, vol. 20, pp. 2577–2592, 2025.</a:t>
             </a:r>
@@ -6017,9 +6018,9 @@
                 <a:solidFill>
                   <a:srgbClr val="898781"/>
                 </a:solidFill>
-                <a:latin typeface="Segoe UI"/>
-              </a:rPr>
-              <a:t>18 / 22</a:t>
+                <a:latin typeface="Calibri"/>
+              </a:rPr>
+              <a:t>18 / 23</a:t>
             </a:r>
           </a:p>
         </p:txBody>
@@ -6069,7 +6070,7 @@
                 <a:solidFill>
                   <a:srgbClr val="0B0B0B"/>
                 </a:solidFill>
-                <a:latin typeface="Segoe UI"/>
+                <a:latin typeface="Calibri"/>
               </a:rPr>
               <a:t>Introduction</a:t>
             </a:r>
@@ -6108,7 +6109,7 @@
                 <a:solidFill>
                   <a:srgbClr val="2A78D6"/>
                 </a:solidFill>
-                <a:latin typeface="Segoe UI"/>
+                <a:latin typeface="Calibri"/>
               </a:rPr>
               <a:t>▪  </a:t>
             </a:r>
@@ -6117,7 +6118,7 @@
                 <a:solidFill>
                   <a:srgbClr val="26251F"/>
                 </a:solidFill>
-                <a:latin typeface="Segoe UI"/>
+                <a:latin typeface="Calibri"/>
               </a:rPr>
               <a:t>Federated learning shares model updates, not raw data, yet </a:t>
             </a:r>
@@ -6126,7 +6127,7 @@
                 <a:solidFill>
                   <a:srgbClr val="0B0B0B"/>
                 </a:solidFill>
-                <a:latin typeface="Segoe UI"/>
+                <a:latin typeface="Calibri"/>
               </a:rPr>
               <a:t>those updates still leak private training data</a:t>
             </a:r>
@@ -6135,7 +6136,7 @@
                 <a:solidFill>
                   <a:srgbClr val="26251F"/>
                 </a:solidFill>
-                <a:latin typeface="Segoe UI"/>
+                <a:latin typeface="Calibri"/>
               </a:rPr>
               <a:t>.</a:t>
             </a:r>
@@ -6151,7 +6152,7 @@
                 <a:solidFill>
                   <a:srgbClr val="2A78D6"/>
                 </a:solidFill>
-                <a:latin typeface="Segoe UI"/>
+                <a:latin typeface="Calibri"/>
               </a:rPr>
               <a:t>▪  </a:t>
             </a:r>
@@ -6160,7 +6161,7 @@
                 <a:solidFill>
                   <a:srgbClr val="26251F"/>
                 </a:solidFill>
-                <a:latin typeface="Segoe UI"/>
+                <a:latin typeface="Calibri"/>
               </a:rPr>
               <a:t>Secure aggregation hides updates behind masks, but its key exchange </a:t>
             </a:r>
@@ -6169,7 +6170,7 @@
                 <a:solidFill>
                   <a:srgbClr val="0B0B0B"/>
                 </a:solidFill>
-                <a:latin typeface="Segoe UI"/>
+                <a:latin typeface="Calibri"/>
               </a:rPr>
               <a:t>breaks under a quantum computer</a:t>
             </a:r>
@@ -6178,7 +6179,7 @@
                 <a:solidFill>
                   <a:srgbClr val="26251F"/>
                 </a:solidFill>
-                <a:latin typeface="Segoe UI"/>
+                <a:latin typeface="Calibri"/>
               </a:rPr>
               <a:t> (harvest-now, decrypt-later).</a:t>
             </a:r>
@@ -6194,7 +6195,7 @@
                 <a:solidFill>
                   <a:srgbClr val="2A78D6"/>
                 </a:solidFill>
-                <a:latin typeface="Segoe UI"/>
+                <a:latin typeface="Calibri"/>
               </a:rPr>
               <a:t>▪  </a:t>
             </a:r>
@@ -6203,7 +6204,7 @@
                 <a:solidFill>
                   <a:srgbClr val="26251F"/>
                 </a:solidFill>
-                <a:latin typeface="Segoe UI"/>
+                <a:latin typeface="Calibri"/>
               </a:rPr>
               <a:t>Every post-quantum fix today is </a:t>
             </a:r>
@@ -6212,7 +6213,7 @@
                 <a:solidFill>
                   <a:srgbClr val="0B0B0B"/>
                 </a:solidFill>
-                <a:latin typeface="Segoe UI"/>
+                <a:latin typeface="Calibri"/>
               </a:rPr>
               <a:t>lattice-only, a monoculture</a:t>
             </a:r>
@@ -6221,7 +6222,7 @@
                 <a:solidFill>
                   <a:srgbClr val="26251F"/>
                 </a:solidFill>
-                <a:latin typeface="Segoe UI"/>
+                <a:latin typeface="Calibri"/>
               </a:rPr>
               <a:t>; and hiding updates also blinds the server to poisoned ones.</a:t>
             </a:r>
@@ -6237,7 +6238,7 @@
                 <a:solidFill>
                   <a:srgbClr val="2A78D6"/>
                 </a:solidFill>
-                <a:latin typeface="Segoe UI"/>
+                <a:latin typeface="Calibri"/>
               </a:rPr>
               <a:t>▪  </a:t>
             </a:r>
@@ -6246,7 +6247,7 @@
                 <a:solidFill>
                   <a:srgbClr val="26251F"/>
                 </a:solidFill>
-                <a:latin typeface="Segoe UI"/>
+                <a:latin typeface="Calibri"/>
               </a:rPr>
               <a:t>Goal: one protocol that is </a:t>
             </a:r>
@@ -6255,7 +6256,7 @@
                 <a:solidFill>
                   <a:srgbClr val="0B0B0B"/>
                 </a:solidFill>
-                <a:latin typeface="Segoe UI"/>
+                <a:latin typeface="Calibri"/>
               </a:rPr>
               <a:t>private, post-quantum with crypto diversity, and Byzantine-robust</a:t>
             </a:r>
@@ -6264,7 +6265,7 @@
                 <a:solidFill>
                   <a:srgbClr val="26251F"/>
                 </a:solidFill>
-                <a:latin typeface="Segoe UI"/>
+                <a:latin typeface="Calibri"/>
               </a:rPr>
               <a:t>.</a:t>
             </a:r>
@@ -6301,9 +6302,9 @@
             <a:r>
               <a:rPr sz="800" b="0" i="1">
                 <a:solidFill>
-                  <a:srgbClr val="2A78D6"/>
-                </a:solidFill>
-                <a:latin typeface="Segoe UI"/>
+                  <a:srgbClr val="26251F"/>
+                </a:solidFill>
+                <a:latin typeface="Calibri"/>
               </a:rPr>
               <a:t>[2] K. Bonawitz, V. Ivanov, B. Kreuter, A. Marcedone, H. B. McMahan, S. Patel, D. Ramage, A. Segal, and K. Seth, "Practical secure aggregation for privacy-preserving machine learning," in Proc. ACM CCS, 2017, pp. 1175–1191.</a:t>
             </a:r>
@@ -6338,9 +6339,9 @@
                 <a:solidFill>
                   <a:srgbClr val="898781"/>
                 </a:solidFill>
-                <a:latin typeface="Segoe UI"/>
-              </a:rPr>
-              <a:t>1 / 22</a:t>
+                <a:latin typeface="Calibri"/>
+              </a:rPr>
+              <a:t>1 / 23</a:t>
             </a:r>
           </a:p>
         </p:txBody>
@@ -6390,9 +6391,9 @@
                 <a:solidFill>
                   <a:srgbClr val="0B0B0B"/>
                 </a:solidFill>
-                <a:latin typeface="Segoe UI"/>
-              </a:rPr>
-              <a:t>Results: Detection</a:t>
+                <a:latin typeface="Calibri"/>
+              </a:rPr>
+              <a:t>Results: Training Dynamics</a:t>
             </a:r>
           </a:p>
         </p:txBody>
@@ -6424,64 +6425,16 @@
                 <a:solidFill>
                   <a:srgbClr val="26251F"/>
                 </a:solidFill>
-                <a:latin typeface="Segoe UI"/>
-              </a:rPr>
-              <a:t>Temporal suspicion separation (from the paper, Fig. 8).</a:t>
-            </a:r>
-          </a:p>
-        </p:txBody>
-      </p:sp>
-      <p:sp>
-        <p:nvSpPr>
-          <p:cNvPr id="4" name="TextBox 3"/>
-          <p:cNvSpPr txBox="1"/>
-          <p:nvPr/>
-        </p:nvSpPr>
-        <p:spPr>
-          <a:xfrm>
-            <a:off x="685800" y="1828800"/>
-            <a:ext cx="10881360" cy="3931920"/>
-          </a:xfrm>
-          <a:prstGeom prst="rect">
-            <a:avLst/>
-          </a:prstGeom>
-          <a:noFill/>
-        </p:spPr>
-        <p:txBody>
-          <a:bodyPr wrap="square">
-            <a:spAutoFit/>
-          </a:bodyPr>
-          <a:lstStyle/>
-          <a:p>
-            <a:pPr>
-              <a:spcAft>
-                <a:spcPts val="800"/>
-              </a:spcAft>
-            </a:pPr>
-            <a:r>
-              <a:rPr sz="1500">
-                <a:solidFill>
-                  <a:srgbClr val="2A78D6"/>
-                </a:solidFill>
-                <a:latin typeface="Segoe UI"/>
-              </a:rPr>
-              <a:t>▪  </a:t>
-            </a:r>
-            <a:r>
-              <a:rPr sz="1500" b="0" i="0">
-                <a:solidFill>
-                  <a:srgbClr val="26251F"/>
-                </a:solidFill>
-                <a:latin typeface="Segoe UI"/>
-              </a:rPr>
-              <a:t>Malicious and honest suspicion separate within a few rounds; attackers are named from group-level observations alone.</a:t>
+                <a:latin typeface="Calibri"/>
+              </a:rPr>
+              <a:t>Test accuracy vs. round for eight rules, over three datasets (rows) and three malicious fractions (columns); CB-SAFE+ tracks the clean baseline while the others diverge (from the paper, Fig. 7).</a:t>
             </a:r>
           </a:p>
         </p:txBody>
       </p:sp>
       <p:pic>
         <p:nvPicPr>
-          <p:cNvPr id="5" name="Picture 4" descr="shot_suspicion_fig.png"/>
+          <p:cNvPr id="4" name="Picture 3" descr="shot_dynamics_fig.png"/>
           <p:cNvPicPr>
             <a:picLocks noChangeAspect="1"/>
           </p:cNvPicPr>
@@ -6495,8 +6448,8 @@
         </p:blipFill>
         <p:spPr>
           <a:xfrm>
-            <a:off x="2306507" y="2514600"/>
-            <a:ext cx="7578681" cy="3108960"/>
+            <a:off x="3602817" y="1965960"/>
+            <a:ext cx="4986061" cy="3913632"/>
           </a:xfrm>
           <a:prstGeom prst="rect">
             <a:avLst/>
@@ -6505,7 +6458,7 @@
       </p:pic>
       <p:sp>
         <p:nvSpPr>
-          <p:cNvPr id="6" name="TextBox 5"/>
+          <p:cNvPr id="5" name="TextBox 4"/>
           <p:cNvSpPr txBox="1"/>
           <p:nvPr/>
         </p:nvSpPr>
@@ -6533,9 +6486,9 @@
             <a:r>
               <a:rPr sz="800" b="0" i="1">
                 <a:solidFill>
-                  <a:srgbClr val="2A78D6"/>
-                </a:solidFill>
-                <a:latin typeface="Segoe UI"/>
+                  <a:srgbClr val="26251F"/>
+                </a:solidFill>
+                <a:latin typeface="Calibri"/>
               </a:rPr>
               <a:t>[1] M. Xhemrishi, J. Östman, A. Wachter-Zeh, and A. Graell i Amat, "FedGT: Identification of malicious clients in federated learning with secure aggregation," IEEE Trans. Inf. Forensics Security, vol. 20, pp. 2577–2592, 2025.</a:t>
             </a:r>
@@ -6544,7 +6497,7 @@
       </p:sp>
       <p:sp>
         <p:nvSpPr>
-          <p:cNvPr id="7" name="TextBox 6"/>
+          <p:cNvPr id="6" name="TextBox 5"/>
           <p:cNvSpPr txBox="1"/>
           <p:nvPr/>
         </p:nvSpPr>
@@ -6570,9 +6523,9 @@
                 <a:solidFill>
                   <a:srgbClr val="898781"/>
                 </a:solidFill>
-                <a:latin typeface="Segoe UI"/>
-              </a:rPr>
-              <a:t>19 / 22</a:t>
+                <a:latin typeface="Calibri"/>
+              </a:rPr>
+              <a:t>19 / 23</a:t>
             </a:r>
           </a:p>
         </p:txBody>
@@ -6622,9 +6575,9 @@
                 <a:solidFill>
                   <a:srgbClr val="0B0B0B"/>
                 </a:solidFill>
-                <a:latin typeface="Segoe UI"/>
-              </a:rPr>
-              <a:t>Results: Generalization</a:t>
+                <a:latin typeface="Calibri"/>
+              </a:rPr>
+              <a:t>Results: Detection</a:t>
             </a:r>
           </a:p>
         </p:txBody>
@@ -6656,9 +6609,9 @@
                 <a:solidFill>
                   <a:srgbClr val="26251F"/>
                 </a:solidFill>
-                <a:latin typeface="Segoe UI"/>
-              </a:rPr>
-              <a:t>Label-flip test accuracy (from the paper, Table VI); CB-SAFE+ matches FedGT and leads at the hardest setting (f=0.3).</a:t>
+                <a:latin typeface="Calibri"/>
+              </a:rPr>
+              <a:t>Temporal suspicion separation (from the paper, Fig. 8).</a:t>
             </a:r>
           </a:p>
         </p:txBody>
@@ -6695,7 +6648,7 @@
                 <a:solidFill>
                   <a:srgbClr val="2A78D6"/>
                 </a:solidFill>
-                <a:latin typeface="Segoe UI"/>
+                <a:latin typeface="Calibri"/>
               </a:rPr>
               <a:t>▪  </a:t>
             </a:r>
@@ -6704,16 +6657,16 @@
                 <a:solidFill>
                   <a:srgbClr val="26251F"/>
                 </a:solidFill>
-                <a:latin typeface="Segoe UI"/>
-              </a:rPr>
-              <a:t>Label-flip is milder: no coordinate-wise rule collapses, which isolates laundering as the cause of the sign-flip failures.</a:t>
+                <a:latin typeface="Calibri"/>
+              </a:rPr>
+              <a:t>Malicious and honest suspicion separate within a few rounds; attackers are named from group-level observations alone.</a:t>
             </a:r>
           </a:p>
         </p:txBody>
       </p:sp>
       <p:pic>
         <p:nvPicPr>
-          <p:cNvPr id="5" name="Picture 4" descr="shot_labelflip_table.png"/>
+          <p:cNvPr id="5" name="Picture 4" descr="shot_suspicion_fig.png"/>
           <p:cNvPicPr>
             <a:picLocks noChangeAspect="1"/>
           </p:cNvPicPr>
@@ -6727,8 +6680,8 @@
         </p:blipFill>
         <p:spPr>
           <a:xfrm>
-            <a:off x="1082746" y="2331720"/>
-            <a:ext cx="10026203" cy="3200400"/>
+            <a:off x="2306507" y="2514600"/>
+            <a:ext cx="7578681" cy="3108960"/>
           </a:xfrm>
           <a:prstGeom prst="rect">
             <a:avLst/>
@@ -6765,9 +6718,9 @@
             <a:r>
               <a:rPr sz="800" b="0" i="1">
                 <a:solidFill>
-                  <a:srgbClr val="2A78D6"/>
-                </a:solidFill>
-                <a:latin typeface="Segoe UI"/>
+                  <a:srgbClr val="26251F"/>
+                </a:solidFill>
+                <a:latin typeface="Calibri"/>
               </a:rPr>
               <a:t>[1] M. Xhemrishi, J. Östman, A. Wachter-Zeh, and A. Graell i Amat, "FedGT: Identification of malicious clients in federated learning with secure aggregation," IEEE Trans. Inf. Forensics Security, vol. 20, pp. 2577–2592, 2025.</a:t>
             </a:r>
@@ -6802,9 +6755,9 @@
                 <a:solidFill>
                   <a:srgbClr val="898781"/>
                 </a:solidFill>
-                <a:latin typeface="Segoe UI"/>
-              </a:rPr>
-              <a:t>20 / 22</a:t>
+                <a:latin typeface="Calibri"/>
+              </a:rPr>
+              <a:t>20 / 23</a:t>
             </a:r>
           </a:p>
         </p:txBody>
@@ -6854,9 +6807,9 @@
                 <a:solidFill>
                   <a:srgbClr val="0B0B0B"/>
                 </a:solidFill>
-                <a:latin typeface="Segoe UI"/>
-              </a:rPr>
-              <a:t>Results: Efficiency</a:t>
+                <a:latin typeface="Calibri"/>
+              </a:rPr>
+              <a:t>Results: Generalization</a:t>
             </a:r>
           </a:p>
         </p:txBody>
@@ -6888,9 +6841,9 @@
                 <a:solidFill>
                   <a:srgbClr val="26251F"/>
                 </a:solidFill>
-                <a:latin typeface="Segoe UI"/>
-              </a:rPr>
-              <a:t>Measured per-client overhead (from the paper, Table II).</a:t>
+                <a:latin typeface="Calibri"/>
+              </a:rPr>
+              <a:t>Label-flip test accuracy (from the paper, Table VI); CB-SAFE+ matches FedGT and leads at the hardest setting (f=0.3).</a:t>
             </a:r>
           </a:p>
         </p:txBody>
@@ -6927,7 +6880,7 @@
                 <a:solidFill>
                   <a:srgbClr val="2A78D6"/>
                 </a:solidFill>
-                <a:latin typeface="Segoe UI"/>
+                <a:latin typeface="Calibri"/>
               </a:rPr>
               <a:t>▪  </a:t>
             </a:r>
@@ -6936,41 +6889,16 @@
                 <a:solidFill>
                   <a:srgbClr val="26251F"/>
                 </a:solidFill>
-                <a:latin typeface="Segoe UI"/>
-              </a:rPr>
-              <a:t>Code-based (HQC) confidentiality gives crypto diversity beyond lattices; ML-KEM swaps in unchanged.</a:t>
-            </a:r>
-          </a:p>
-          <a:p>
-            <a:pPr>
-              <a:spcAft>
-                <a:spcPts val="800"/>
-              </a:spcAft>
-            </a:pPr>
-            <a:r>
-              <a:rPr sz="1500">
-                <a:solidFill>
-                  <a:srgbClr val="2A78D6"/>
-                </a:solidFill>
-                <a:latin typeface="Segoe UI"/>
-              </a:rPr>
-              <a:t>▪  </a:t>
-            </a:r>
-            <a:r>
-              <a:rPr sz="1500" b="0" i="0">
-                <a:solidFill>
-                  <a:srgbClr val="26251F"/>
-                </a:solidFill>
-                <a:latin typeface="Segoe UI"/>
-              </a:rPr>
-              <a:t>One-time setup is paid once and stays under 0.03% of total traffic; per-round bytes are KEM-independent.</a:t>
+                <a:latin typeface="Calibri"/>
+              </a:rPr>
+              <a:t>Label-flip is milder: no coordinate-wise rule collapses, which isolates laundering as the cause of the sign-flip failures.</a:t>
             </a:r>
           </a:p>
         </p:txBody>
       </p:sp>
       <p:pic>
         <p:nvPicPr>
-          <p:cNvPr id="5" name="Picture 4" descr="shot_overhead_table.png"/>
+          <p:cNvPr id="5" name="Picture 4" descr="shot_labelflip_table.png"/>
           <p:cNvPicPr>
             <a:picLocks noChangeAspect="1"/>
           </p:cNvPicPr>
@@ -6984,8 +6912,8 @@
         </p:blipFill>
         <p:spPr>
           <a:xfrm>
-            <a:off x="2856259" y="3063240"/>
-            <a:ext cx="6479177" cy="2926080"/>
+            <a:off x="1082746" y="2331720"/>
+            <a:ext cx="10026203" cy="3200400"/>
           </a:xfrm>
           <a:prstGeom prst="rect">
             <a:avLst/>
@@ -7022,27 +6950,11 @@
             <a:r>
               <a:rPr sz="800" b="0" i="1">
                 <a:solidFill>
-                  <a:srgbClr val="2A78D6"/>
-                </a:solidFill>
-                <a:latin typeface="Segoe UI"/>
-              </a:rPr>
-              <a:t>[3] National Institute of Standards and Technology, "Status report on the fourth round of the NIST post-quantum cryptography standardization process," NIST IR 8545, Mar. 2025.</a:t>
-            </a:r>
-          </a:p>
-          <a:p>
-            <a:pPr>
-              <a:spcAft>
-                <a:spcPts val="100"/>
-              </a:spcAft>
-            </a:pPr>
-            <a:r>
-              <a:rPr sz="800" b="0" i="1">
-                <a:solidFill>
-                  <a:srgbClr val="2A78D6"/>
-                </a:solidFill>
-                <a:latin typeface="Segoe UI"/>
-              </a:rPr>
-              <a:t>[9] National Institute of Standards and Technology, "Module-lattice-based key-encapsulation mechanism standard," FIPS 203, Aug. 2024.</a:t>
+                  <a:srgbClr val="26251F"/>
+                </a:solidFill>
+                <a:latin typeface="Calibri"/>
+              </a:rPr>
+              <a:t>[1] M. Xhemrishi, J. Östman, A. Wachter-Zeh, and A. Graell i Amat, "FedGT: Identification of malicious clients in federated learning with secure aggregation," IEEE Trans. Inf. Forensics Security, vol. 20, pp. 2577–2592, 2025.</a:t>
             </a:r>
           </a:p>
         </p:txBody>
@@ -7075,9 +6987,9 @@
                 <a:solidFill>
                   <a:srgbClr val="898781"/>
                 </a:solidFill>
-                <a:latin typeface="Segoe UI"/>
-              </a:rPr>
-              <a:t>21 / 22</a:t>
+                <a:latin typeface="Calibri"/>
+              </a:rPr>
+              <a:t>21 / 23</a:t>
             </a:r>
           </a:p>
         </p:txBody>
@@ -7127,9 +7039,9 @@
                 <a:solidFill>
                   <a:srgbClr val="0B0B0B"/>
                 </a:solidFill>
-                <a:latin typeface="Segoe UI"/>
-              </a:rPr>
-              <a:t>Conclusion</a:t>
+                <a:latin typeface="Calibri"/>
+              </a:rPr>
+              <a:t>Results: Efficiency</a:t>
             </a:r>
           </a:p>
         </p:txBody>
@@ -7143,6 +7055,40 @@
         <p:spPr>
           <a:xfrm>
             <a:off x="685800" y="1371600"/>
+            <a:ext cx="10881360" cy="457200"/>
+          </a:xfrm>
+          <a:prstGeom prst="rect">
+            <a:avLst/>
+          </a:prstGeom>
+          <a:noFill/>
+        </p:spPr>
+        <p:txBody>
+          <a:bodyPr wrap="square">
+            <a:spAutoFit/>
+          </a:bodyPr>
+          <a:lstStyle/>
+          <a:p>
+            <a:r>
+              <a:rPr sz="1400" b="0" i="1">
+                <a:solidFill>
+                  <a:srgbClr val="26251F"/>
+                </a:solidFill>
+                <a:latin typeface="Calibri"/>
+              </a:rPr>
+              <a:t>Measured per-client overhead (from the paper, Table II).</a:t>
+            </a:r>
+          </a:p>
+        </p:txBody>
+      </p:sp>
+      <p:sp>
+        <p:nvSpPr>
+          <p:cNvPr id="4" name="TextBox 3"/>
+          <p:cNvSpPr txBox="1"/>
+          <p:nvPr/>
+        </p:nvSpPr>
+        <p:spPr>
+          <a:xfrm>
+            <a:off x="685800" y="1828800"/>
             <a:ext cx="10881360" cy="3931920"/>
           </a:xfrm>
           <a:prstGeom prst="rect">
@@ -7166,7 +7112,7 @@
                 <a:solidFill>
                   <a:srgbClr val="2A78D6"/>
                 </a:solidFill>
-                <a:latin typeface="Segoe UI"/>
+                <a:latin typeface="Calibri"/>
               </a:rPr>
               <a:t>▪  </a:t>
             </a:r>
@@ -7175,9 +7121,9 @@
                 <a:solidFill>
                   <a:srgbClr val="26251F"/>
                 </a:solidFill>
-                <a:latin typeface="Segoe UI"/>
-              </a:rPr>
-              <a:t>CB-SAFE unifies code-based PQ secure aggregation with temporal group-testing robustness in one protocol.</a:t>
+                <a:latin typeface="Calibri"/>
+              </a:rPr>
+              <a:t>Code-based (HQC) confidentiality gives crypto diversity beyond lattices; ML-KEM swaps in unchanged.</a:t>
             </a:r>
           </a:p>
           <a:p>
@@ -7191,7 +7137,7 @@
                 <a:solidFill>
                   <a:srgbClr val="2A78D6"/>
                 </a:solidFill>
-                <a:latin typeface="Segoe UI"/>
+                <a:latin typeface="Calibri"/>
               </a:rPr>
               <a:t>▪  </a:t>
             </a:r>
@@ -7200,66 +7146,40 @@
                 <a:solidFill>
                   <a:srgbClr val="26251F"/>
                 </a:solidFill>
-                <a:latin typeface="Segoe UI"/>
-              </a:rPr>
-              <a:t>It ties the state of the art (FedGT) on robustness and detection, at lower cost, and adds crypto diversity plus a failure theory.</a:t>
-            </a:r>
-          </a:p>
-          <a:p>
-            <a:pPr>
-              <a:spcAft>
-                <a:spcPts val="800"/>
-              </a:spcAft>
-            </a:pPr>
-            <a:r>
-              <a:rPr sz="1500">
-                <a:solidFill>
-                  <a:srgbClr val="2A78D6"/>
-                </a:solidFill>
-                <a:latin typeface="Segoe UI"/>
-              </a:rPr>
-              <a:t>▪  </a:t>
-            </a:r>
-            <a:r>
-              <a:rPr sz="1500" b="0" i="0">
-                <a:solidFill>
-                  <a:srgbClr val="26251F"/>
-                </a:solidFill>
-                <a:latin typeface="Segoe UI"/>
-              </a:rPr>
-              <a:t>Limitations: update authentication is out of the code-based scope; EMNIST detection uses a single seed.</a:t>
-            </a:r>
-          </a:p>
-          <a:p>
-            <a:pPr>
-              <a:spcAft>
-                <a:spcPts val="800"/>
-              </a:spcAft>
-            </a:pPr>
-            <a:r>
-              <a:rPr sz="1500">
-                <a:solidFill>
-                  <a:srgbClr val="2A78D6"/>
-                </a:solidFill>
-                <a:latin typeface="Segoe UI"/>
-              </a:rPr>
-              <a:t>▪  </a:t>
-            </a:r>
-            <a:r>
-              <a:rPr sz="1500" b="0" i="0">
-                <a:solidFill>
-                  <a:srgbClr val="26251F"/>
-                </a:solidFill>
-                <a:latin typeface="Segoe UI"/>
-              </a:rPr>
-              <a:t>Future work: code-based signatures for authentication, larger client populations, and adaptive attackers.</a:t>
-            </a:r>
-          </a:p>
-        </p:txBody>
-      </p:sp>
-      <p:sp>
-        <p:nvSpPr>
-          <p:cNvPr id="4" name="TextBox 3"/>
+                <a:latin typeface="Calibri"/>
+              </a:rPr>
+              <a:t>One-time setup is paid once and stays under 0.03% of total traffic; per-round bytes are KEM-independent.</a:t>
+            </a:r>
+          </a:p>
+        </p:txBody>
+      </p:sp>
+      <p:pic>
+        <p:nvPicPr>
+          <p:cNvPr id="5" name="Picture 4" descr="shot_overhead_table.png"/>
+          <p:cNvPicPr>
+            <a:picLocks noChangeAspect="1"/>
+          </p:cNvPicPr>
+          <p:nvPr/>
+        </p:nvPicPr>
+        <p:blipFill>
+          <a:blip r:embed="rId2"/>
+          <a:stretch>
+            <a:fillRect/>
+          </a:stretch>
+        </p:blipFill>
+        <p:spPr>
+          <a:xfrm>
+            <a:off x="2856259" y="3063240"/>
+            <a:ext cx="6479177" cy="2926080"/>
+          </a:xfrm>
+          <a:prstGeom prst="rect">
+            <a:avLst/>
+          </a:prstGeom>
+        </p:spPr>
+      </p:pic>
+      <p:sp>
+        <p:nvSpPr>
+          <p:cNvPr id="6" name="TextBox 5"/>
           <p:cNvSpPr txBox="1"/>
           <p:nvPr/>
         </p:nvSpPr>
@@ -7287,11 +7207,11 @@
             <a:r>
               <a:rPr sz="800" b="0" i="1">
                 <a:solidFill>
-                  <a:srgbClr val="2A78D6"/>
-                </a:solidFill>
-                <a:latin typeface="Segoe UI"/>
-              </a:rPr>
-              <a:t>[1] M. Xhemrishi, J. Östman, A. Wachter-Zeh, and A. Graell i Amat, "FedGT: Identification of malicious clients in federated learning with secure aggregation," IEEE Trans. Inf. Forensics Security, vol. 20, pp. 2577–2592, 2025.</a:t>
+                  <a:srgbClr val="26251F"/>
+                </a:solidFill>
+                <a:latin typeface="Calibri"/>
+              </a:rPr>
+              <a:t>[3] National Institute of Standards and Technology, "Status report on the fourth round of the NIST post-quantum cryptography standardization process," NIST IR 8545, Mar. 2025.</a:t>
             </a:r>
           </a:p>
           <a:p>
@@ -7303,34 +7223,18 @@
             <a:r>
               <a:rPr sz="800" b="0" i="1">
                 <a:solidFill>
-                  <a:srgbClr val="2A78D6"/>
-                </a:solidFill>
-                <a:latin typeface="Segoe UI"/>
-              </a:rPr>
-              <a:t>[2] K. Bonawitz, V. Ivanov, B. Kreuter, A. Marcedone, H. B. McMahan, S. Patel, D. Ramage, A. Segal, and K. Seth, "Practical secure aggregation for privacy-preserving machine learning," in Proc. ACM CCS, 2017, pp. 1175–1191.</a:t>
-            </a:r>
-          </a:p>
-          <a:p>
-            <a:pPr>
-              <a:spcAft>
-                <a:spcPts val="100"/>
-              </a:spcAft>
-            </a:pPr>
-            <a:r>
-              <a:rPr sz="800" b="0" i="1">
-                <a:solidFill>
-                  <a:srgbClr val="2A78D6"/>
-                </a:solidFill>
-                <a:latin typeface="Segoe UI"/>
-              </a:rPr>
-              <a:t>[3] National Institute of Standards and Technology, "Status report on the fourth round of the NIST post-quantum cryptography standardization process," NIST IR 8545, Mar. 2025.</a:t>
-            </a:r>
-          </a:p>
-        </p:txBody>
-      </p:sp>
-      <p:sp>
-        <p:nvSpPr>
-          <p:cNvPr id="5" name="TextBox 4"/>
+                  <a:srgbClr val="26251F"/>
+                </a:solidFill>
+                <a:latin typeface="Calibri"/>
+              </a:rPr>
+              <a:t>[9] National Institute of Standards and Technology, "Module-lattice-based key-encapsulation mechanism standard," FIPS 203, Aug. 2024.</a:t>
+            </a:r>
+          </a:p>
+        </p:txBody>
+      </p:sp>
+      <p:sp>
+        <p:nvSpPr>
+          <p:cNvPr id="7" name="TextBox 6"/>
           <p:cNvSpPr txBox="1"/>
           <p:nvPr/>
         </p:nvSpPr>
@@ -7356,9 +7260,9 @@
                 <a:solidFill>
                   <a:srgbClr val="898781"/>
                 </a:solidFill>
-                <a:latin typeface="Segoe UI"/>
-              </a:rPr>
-              <a:t>22 / 22</a:t>
+                <a:latin typeface="Calibri"/>
+              </a:rPr>
+              <a:t>22 / 23</a:t>
             </a:r>
           </a:p>
         </p:txBody>
@@ -7408,7 +7312,288 @@
                 <a:solidFill>
                   <a:srgbClr val="0B0B0B"/>
                 </a:solidFill>
-                <a:latin typeface="Segoe UI"/>
+                <a:latin typeface="Calibri"/>
+              </a:rPr>
+              <a:t>Conclusion</a:t>
+            </a:r>
+          </a:p>
+        </p:txBody>
+      </p:sp>
+      <p:sp>
+        <p:nvSpPr>
+          <p:cNvPr id="3" name="TextBox 2"/>
+          <p:cNvSpPr txBox="1"/>
+          <p:nvPr/>
+        </p:nvSpPr>
+        <p:spPr>
+          <a:xfrm>
+            <a:off x="685800" y="1371600"/>
+            <a:ext cx="10881360" cy="3931920"/>
+          </a:xfrm>
+          <a:prstGeom prst="rect">
+            <a:avLst/>
+          </a:prstGeom>
+          <a:noFill/>
+        </p:spPr>
+        <p:txBody>
+          <a:bodyPr wrap="square">
+            <a:spAutoFit/>
+          </a:bodyPr>
+          <a:lstStyle/>
+          <a:p>
+            <a:pPr>
+              <a:spcAft>
+                <a:spcPts val="800"/>
+              </a:spcAft>
+            </a:pPr>
+            <a:r>
+              <a:rPr sz="1500">
+                <a:solidFill>
+                  <a:srgbClr val="2A78D6"/>
+                </a:solidFill>
+                <a:latin typeface="Calibri"/>
+              </a:rPr>
+              <a:t>▪  </a:t>
+            </a:r>
+            <a:r>
+              <a:rPr sz="1500" b="0" i="0">
+                <a:solidFill>
+                  <a:srgbClr val="26251F"/>
+                </a:solidFill>
+                <a:latin typeface="Calibri"/>
+              </a:rPr>
+              <a:t>CB-SAFE unifies code-based PQ secure aggregation with temporal group-testing robustness in one protocol.</a:t>
+            </a:r>
+          </a:p>
+          <a:p>
+            <a:pPr>
+              <a:spcAft>
+                <a:spcPts val="800"/>
+              </a:spcAft>
+            </a:pPr>
+            <a:r>
+              <a:rPr sz="1500">
+                <a:solidFill>
+                  <a:srgbClr val="2A78D6"/>
+                </a:solidFill>
+                <a:latin typeface="Calibri"/>
+              </a:rPr>
+              <a:t>▪  </a:t>
+            </a:r>
+            <a:r>
+              <a:rPr sz="1500" b="0" i="0">
+                <a:solidFill>
+                  <a:srgbClr val="26251F"/>
+                </a:solidFill>
+                <a:latin typeface="Calibri"/>
+              </a:rPr>
+              <a:t>It ties the state of the art (FedGT) on robustness and detection, at lower cost, and adds crypto diversity plus a failure theory.</a:t>
+            </a:r>
+          </a:p>
+          <a:p>
+            <a:pPr>
+              <a:spcAft>
+                <a:spcPts val="800"/>
+              </a:spcAft>
+            </a:pPr>
+            <a:r>
+              <a:rPr sz="1500">
+                <a:solidFill>
+                  <a:srgbClr val="2A78D6"/>
+                </a:solidFill>
+                <a:latin typeface="Calibri"/>
+              </a:rPr>
+              <a:t>▪  </a:t>
+            </a:r>
+            <a:r>
+              <a:rPr sz="1500" b="0" i="0">
+                <a:solidFill>
+                  <a:srgbClr val="26251F"/>
+                </a:solidFill>
+                <a:latin typeface="Calibri"/>
+              </a:rPr>
+              <a:t>Limitations: update authentication is out of the code-based scope; EMNIST detection uses a single seed.</a:t>
+            </a:r>
+          </a:p>
+          <a:p>
+            <a:pPr>
+              <a:spcAft>
+                <a:spcPts val="800"/>
+              </a:spcAft>
+            </a:pPr>
+            <a:r>
+              <a:rPr sz="1500">
+                <a:solidFill>
+                  <a:srgbClr val="2A78D6"/>
+                </a:solidFill>
+                <a:latin typeface="Calibri"/>
+              </a:rPr>
+              <a:t>▪  </a:t>
+            </a:r>
+            <a:r>
+              <a:rPr sz="1500" b="0" i="0">
+                <a:solidFill>
+                  <a:srgbClr val="26251F"/>
+                </a:solidFill>
+                <a:latin typeface="Calibri"/>
+              </a:rPr>
+              <a:t>Future work: code-based signatures for authentication, larger client populations, and adaptive attackers.</a:t>
+            </a:r>
+          </a:p>
+        </p:txBody>
+      </p:sp>
+      <p:sp>
+        <p:nvSpPr>
+          <p:cNvPr id="4" name="TextBox 3"/>
+          <p:cNvSpPr txBox="1"/>
+          <p:nvPr/>
+        </p:nvSpPr>
+        <p:spPr>
+          <a:xfrm>
+            <a:off x="685800" y="5943600"/>
+            <a:ext cx="10881360" cy="502920"/>
+          </a:xfrm>
+          <a:prstGeom prst="rect">
+            <a:avLst/>
+          </a:prstGeom>
+          <a:noFill/>
+        </p:spPr>
+        <p:txBody>
+          <a:bodyPr wrap="square">
+            <a:spAutoFit/>
+          </a:bodyPr>
+          <a:lstStyle/>
+          <a:p>
+            <a:pPr>
+              <a:spcAft>
+                <a:spcPts val="100"/>
+              </a:spcAft>
+            </a:pPr>
+            <a:r>
+              <a:rPr sz="800" b="0" i="1">
+                <a:solidFill>
+                  <a:srgbClr val="26251F"/>
+                </a:solidFill>
+                <a:latin typeface="Calibri"/>
+              </a:rPr>
+              <a:t>[1] M. Xhemrishi, J. Östman, A. Wachter-Zeh, and A. Graell i Amat, "FedGT: Identification of malicious clients in federated learning with secure aggregation," IEEE Trans. Inf. Forensics Security, vol. 20, pp. 2577–2592, 2025.</a:t>
+            </a:r>
+          </a:p>
+          <a:p>
+            <a:pPr>
+              <a:spcAft>
+                <a:spcPts val="100"/>
+              </a:spcAft>
+            </a:pPr>
+            <a:r>
+              <a:rPr sz="800" b="0" i="1">
+                <a:solidFill>
+                  <a:srgbClr val="26251F"/>
+                </a:solidFill>
+                <a:latin typeface="Calibri"/>
+              </a:rPr>
+              <a:t>[2] K. Bonawitz, V. Ivanov, B. Kreuter, A. Marcedone, H. B. McMahan, S. Patel, D. Ramage, A. Segal, and K. Seth, "Practical secure aggregation for privacy-preserving machine learning," in Proc. ACM CCS, 2017, pp. 1175–1191.</a:t>
+            </a:r>
+          </a:p>
+          <a:p>
+            <a:pPr>
+              <a:spcAft>
+                <a:spcPts val="100"/>
+              </a:spcAft>
+            </a:pPr>
+            <a:r>
+              <a:rPr sz="800" b="0" i="1">
+                <a:solidFill>
+                  <a:srgbClr val="26251F"/>
+                </a:solidFill>
+                <a:latin typeface="Calibri"/>
+              </a:rPr>
+              <a:t>[3] National Institute of Standards and Technology, "Status report on the fourth round of the NIST post-quantum cryptography standardization process," NIST IR 8545, Mar. 2025.</a:t>
+            </a:r>
+          </a:p>
+        </p:txBody>
+      </p:sp>
+      <p:sp>
+        <p:nvSpPr>
+          <p:cNvPr id="5" name="TextBox 4"/>
+          <p:cNvSpPr txBox="1"/>
+          <p:nvPr/>
+        </p:nvSpPr>
+        <p:spPr>
+          <a:xfrm>
+            <a:off x="11018520" y="6446520"/>
+            <a:ext cx="914400" cy="274320"/>
+          </a:xfrm>
+          <a:prstGeom prst="rect">
+            <a:avLst/>
+          </a:prstGeom>
+          <a:noFill/>
+        </p:spPr>
+        <p:txBody>
+          <a:bodyPr wrap="square">
+            <a:spAutoFit/>
+          </a:bodyPr>
+          <a:lstStyle/>
+          <a:p>
+            <a:pPr algn="r"/>
+            <a:r>
+              <a:rPr sz="1050" b="0" i="0">
+                <a:solidFill>
+                  <a:srgbClr val="898781"/>
+                </a:solidFill>
+                <a:latin typeface="Calibri"/>
+              </a:rPr>
+              <a:t>23 / 23</a:t>
+            </a:r>
+          </a:p>
+        </p:txBody>
+      </p:sp>
+    </p:spTree>
+  </p:cSld>
+  <p:clrMapOvr>
+    <a:masterClrMapping/>
+  </p:clrMapOvr>
+</p:sld>
+</file>
+
+<file path=ppt/slides/slide25.xml><?xml version="1.0" encoding="utf-8"?>
+<p:sld xmlns:a="http://schemas.openxmlformats.org/drawingml/2006/main" xmlns:p="http://schemas.openxmlformats.org/presentationml/2006/main" xmlns:r="http://schemas.openxmlformats.org/officeDocument/2006/relationships">
+  <p:cSld>
+    <p:spTree>
+      <p:nvGrpSpPr>
+        <p:cNvPr id="1" name=""/>
+        <p:cNvGrpSpPr/>
+        <p:nvPr/>
+      </p:nvGrpSpPr>
+      <p:grpSpPr/>
+      <p:sp>
+        <p:nvSpPr>
+          <p:cNvPr id="2" name="TextBox 1"/>
+          <p:cNvSpPr txBox="1"/>
+          <p:nvPr/>
+        </p:nvSpPr>
+        <p:spPr>
+          <a:xfrm>
+            <a:off x="685800" y="438912"/>
+            <a:ext cx="10881360" cy="822960"/>
+          </a:xfrm>
+          <a:prstGeom prst="rect">
+            <a:avLst/>
+          </a:prstGeom>
+          <a:noFill/>
+        </p:spPr>
+        <p:txBody>
+          <a:bodyPr wrap="square">
+            <a:spAutoFit/>
+          </a:bodyPr>
+          <a:lstStyle/>
+          <a:p>
+            <a:r>
+              <a:rPr sz="3000" b="1" i="0">
+                <a:solidFill>
+                  <a:srgbClr val="0B0B0B"/>
+                </a:solidFill>
+                <a:latin typeface="Calibri"/>
               </a:rPr>
               <a:t>References</a:t>
             </a:r>
@@ -7447,7 +7632,7 @@
                 <a:solidFill>
                   <a:srgbClr val="26251F"/>
                 </a:solidFill>
-                <a:latin typeface="Segoe UI"/>
+                <a:latin typeface="Calibri"/>
               </a:rPr>
               <a:t>[1] M. Xhemrishi, J. Östman, A. Wachter-Zeh, and A. Graell i Amat, "FedGT: Identification of malicious clients in federated learning with secure aggregation," IEEE Trans. Inf. Forensics Security, vol. 20, pp. 2577–2592, 2025.</a:t>
             </a:r>
@@ -7463,7 +7648,7 @@
                 <a:solidFill>
                   <a:srgbClr val="26251F"/>
                 </a:solidFill>
-                <a:latin typeface="Segoe UI"/>
+                <a:latin typeface="Calibri"/>
               </a:rPr>
               <a:t>[2] K. Bonawitz, V. Ivanov, B. Kreuter, A. Marcedone, H. B. McMahan, S. Patel, D. Ramage, A. Segal, and K. Seth, "Practical secure aggregation for privacy-preserving machine learning," in Proc. ACM CCS, 2017, pp. 1175–1191.</a:t>
             </a:r>
@@ -7479,7 +7664,7 @@
                 <a:solidFill>
                   <a:srgbClr val="26251F"/>
                 </a:solidFill>
-                <a:latin typeface="Segoe UI"/>
+                <a:latin typeface="Calibri"/>
               </a:rPr>
               <a:t>[3] National Institute of Standards and Technology, "Status report on the fourth round of the NIST post-quantum cryptography standardization process," NIST IR 8545, Mar. 2025.</a:t>
             </a:r>
@@ -7495,7 +7680,7 @@
                 <a:solidFill>
                   <a:srgbClr val="26251F"/>
                 </a:solidFill>
-                <a:latin typeface="Segoe UI"/>
+                <a:latin typeface="Calibri"/>
               </a:rPr>
               <a:t>[4] P. W. Shor, "Polynomial-time algorithms for prime factorization and discrete logarithms on a quantum computer," SIAM J. Comput., vol. 26, no. 5, pp. 1484–1509, 1997.</a:t>
             </a:r>
@@ -7511,7 +7696,7 @@
                 <a:solidFill>
                   <a:srgbClr val="26251F"/>
                 </a:solidFill>
-                <a:latin typeface="Segoe UI"/>
+                <a:latin typeface="Calibri"/>
               </a:rPr>
               <a:t>[5] X. Cao, M. Fang, J. Liu, and N. Z. Gong, "FLTrust: Byzantine-robust federated learning via trust bootstrapping," in Proc. NDSS, 2021.</a:t>
             </a:r>
@@ -7527,7 +7712,7 @@
                 <a:solidFill>
                   <a:srgbClr val="26251F"/>
                 </a:solidFill>
-                <a:latin typeface="Segoe UI"/>
+                <a:latin typeface="Calibri"/>
               </a:rPr>
               <a:t>[6] D. Yin, Y. Chen, R. Kannan, and P. Bartlett, "Byzantine-robust distributed learning: Towards optimal statistical rates," in Proc. ICML, 2018, pp. 5650–5659.</a:t>
             </a:r>
@@ -7543,7 +7728,7 @@
                 <a:solidFill>
                   <a:srgbClr val="26251F"/>
                 </a:solidFill>
-                <a:latin typeface="Segoe UI"/>
+                <a:latin typeface="Calibri"/>
               </a:rPr>
               <a:t>[7] P. Blanchard, E. M. El Mhamdi, R. Guerraoui, and J. Stainer, "Machine learning with adversaries: Byzantine tolerant gradient descent," in Proc. NeurIPS, 2017, pp. 119–129.</a:t>
             </a:r>
@@ -7559,7 +7744,7 @@
                 <a:solidFill>
                   <a:srgbClr val="26251F"/>
                 </a:solidFill>
-                <a:latin typeface="Segoe UI"/>
+                <a:latin typeface="Calibri"/>
               </a:rPr>
               <a:t>[8] K. Pillutla, S. M. Kakade, and Z. Harchaoui, "Robust aggregation for federated learning," IEEE Trans. Signal Process., vol. 70, pp. 1142–1154, 2022.</a:t>
             </a:r>
@@ -7575,7 +7760,7 @@
                 <a:solidFill>
                   <a:srgbClr val="26251F"/>
                 </a:solidFill>
-                <a:latin typeface="Segoe UI"/>
+                <a:latin typeface="Calibri"/>
               </a:rPr>
               <a:t>[9] National Institute of Standards and Technology, "Module-lattice-based key-encapsulation mechanism standard," FIPS 203, Aug. 2024.</a:t>
             </a:r>
@@ -7627,7 +7812,7 @@
                 <a:solidFill>
                   <a:srgbClr val="0B0B0B"/>
                 </a:solidFill>
-                <a:latin typeface="Segoe UI"/>
+                <a:latin typeface="Calibri"/>
               </a:rPr>
               <a:t>Background and Motivation</a:t>
             </a:r>
@@ -7666,7 +7851,7 @@
                 <a:solidFill>
                   <a:srgbClr val="2A78D6"/>
                 </a:solidFill>
-                <a:latin typeface="Segoe UI"/>
+                <a:latin typeface="Calibri"/>
               </a:rPr>
               <a:t>▪  </a:t>
             </a:r>
@@ -7675,7 +7860,7 @@
                 <a:solidFill>
                   <a:srgbClr val="26251F"/>
                 </a:solidFill>
-                <a:latin typeface="Segoe UI"/>
+                <a:latin typeface="Calibri"/>
               </a:rPr>
               <a:t>Secure aggregation = pairwise masks that cancel in the sum; the server sees only the aggregate, never an individual.</a:t>
             </a:r>
@@ -7691,7 +7876,7 @@
                 <a:solidFill>
                   <a:srgbClr val="2A78D6"/>
                 </a:solidFill>
-                <a:latin typeface="Segoe UI"/>
+                <a:latin typeface="Calibri"/>
               </a:rPr>
               <a:t>▪  </a:t>
             </a:r>
@@ -7700,7 +7885,7 @@
                 <a:solidFill>
                   <a:srgbClr val="26251F"/>
                 </a:solidFill>
-                <a:latin typeface="Segoe UI"/>
+                <a:latin typeface="Calibri"/>
               </a:rPr>
               <a:t>Quantum threat: Shor's algorithm breaks classical key exchange, and traffic recorded today is decryptable later.</a:t>
             </a:r>
@@ -7716,7 +7901,7 @@
                 <a:solidFill>
                   <a:srgbClr val="2A78D6"/>
                 </a:solidFill>
-                <a:latin typeface="Segoe UI"/>
+                <a:latin typeface="Calibri"/>
               </a:rPr>
               <a:t>▪  </a:t>
             </a:r>
@@ -7725,7 +7910,7 @@
                 <a:solidFill>
                   <a:srgbClr val="26251F"/>
                 </a:solidFill>
-                <a:latin typeface="Segoe UI"/>
+                <a:latin typeface="Calibri"/>
               </a:rPr>
               <a:t>Crypto diversity: NIST selected the code-based KEM HQC in 2025 to hedge a lattice break; that diversity has not reached FL.</a:t>
             </a:r>
@@ -7741,7 +7926,7 @@
                 <a:solidFill>
                   <a:srgbClr val="2A78D6"/>
                 </a:solidFill>
-                <a:latin typeface="Segoe UI"/>
+                <a:latin typeface="Calibri"/>
               </a:rPr>
               <a:t>▪  </a:t>
             </a:r>
@@ -7750,7 +7935,7 @@
                 <a:solidFill>
                   <a:srgbClr val="26251F"/>
                 </a:solidFill>
-                <a:latin typeface="Segoe UI"/>
+                <a:latin typeface="Calibri"/>
               </a:rPr>
               <a:t>Robustness tension: privacy hides exactly the per-client signal that poisoning defenses need.</a:t>
             </a:r>
@@ -7787,9 +7972,9 @@
             <a:r>
               <a:rPr sz="800" b="0" i="1">
                 <a:solidFill>
-                  <a:srgbClr val="2A78D6"/>
-                </a:solidFill>
-                <a:latin typeface="Segoe UI"/>
+                  <a:srgbClr val="26251F"/>
+                </a:solidFill>
+                <a:latin typeface="Calibri"/>
               </a:rPr>
               <a:t>[3] National Institute of Standards and Technology, "Status report on the fourth round of the NIST post-quantum cryptography standardization process," NIST IR 8545, Mar. 2025.</a:t>
             </a:r>
@@ -7803,9 +7988,9 @@
             <a:r>
               <a:rPr sz="800" b="0" i="1">
                 <a:solidFill>
-                  <a:srgbClr val="2A78D6"/>
-                </a:solidFill>
-                <a:latin typeface="Segoe UI"/>
+                  <a:srgbClr val="26251F"/>
+                </a:solidFill>
+                <a:latin typeface="Calibri"/>
               </a:rPr>
               <a:t>[4] P. W. Shor, "Polynomial-time algorithms for prime factorization and discrete logarithms on a quantum computer," SIAM J. Comput., vol. 26, no. 5, pp. 1484–1509, 1997.</a:t>
             </a:r>
@@ -7840,9 +8025,9 @@
                 <a:solidFill>
                   <a:srgbClr val="898781"/>
                 </a:solidFill>
-                <a:latin typeface="Segoe UI"/>
-              </a:rPr>
-              <a:t>2 / 22</a:t>
+                <a:latin typeface="Calibri"/>
+              </a:rPr>
+              <a:t>2 / 23</a:t>
             </a:r>
           </a:p>
         </p:txBody>
@@ -7892,7 +8077,7 @@
                 <a:solidFill>
                   <a:srgbClr val="0B0B0B"/>
                 </a:solidFill>
-                <a:latin typeface="Segoe UI"/>
+                <a:latin typeface="Calibri"/>
               </a:rPr>
               <a:t>Related Work</a:t>
             </a:r>
@@ -7931,7 +8116,7 @@
                 <a:solidFill>
                   <a:srgbClr val="2A78D6"/>
                 </a:solidFill>
-                <a:latin typeface="Segoe UI"/>
+                <a:latin typeface="Calibri"/>
               </a:rPr>
               <a:t>▪  </a:t>
             </a:r>
@@ -7940,7 +8125,7 @@
                 <a:solidFill>
                   <a:srgbClr val="26251F"/>
                 </a:solidFill>
-                <a:latin typeface="Segoe UI"/>
+                <a:latin typeface="Calibri"/>
               </a:rPr>
               <a:t>FedGT (IEEE TIFS, 2025) is the closest peer to our robustness mechanism.</a:t>
             </a:r>
@@ -7956,7 +8141,7 @@
                 <a:solidFill>
                   <a:srgbClr val="2A78D6"/>
                 </a:solidFill>
-                <a:latin typeface="Segoe UI"/>
+                <a:latin typeface="Calibri"/>
               </a:rPr>
               <a:t>▪  </a:t>
             </a:r>
@@ -7965,7 +8150,7 @@
                 <a:solidFill>
                   <a:srgbClr val="26251F"/>
                 </a:solidFill>
-                <a:latin typeface="Segoe UI"/>
+                <a:latin typeface="Calibri"/>
               </a:rPr>
               <a:t>Idea: group clients into overlapping test groups; the server sees only group aggregates, so privacy is preserved.</a:t>
             </a:r>
@@ -7981,7 +8166,7 @@
                 <a:solidFill>
                   <a:srgbClr val="2A78D6"/>
                 </a:solidFill>
-                <a:latin typeface="Segoe UI"/>
+                <a:latin typeface="Calibri"/>
               </a:rPr>
               <a:t>▪  </a:t>
             </a:r>
@@ -7990,7 +8175,7 @@
                 <a:solidFill>
                   <a:srgbClr val="26251F"/>
                 </a:solidFill>
-                <a:latin typeface="Segoe UI"/>
+                <a:latin typeface="Calibri"/>
               </a:rPr>
               <a:t>A statistical test flags groups that contain malicious clients; a decoder then identifies and removes the culprits.</a:t>
             </a:r>
@@ -8006,7 +8191,7 @@
                 <a:solidFill>
                   <a:srgbClr val="2A78D6"/>
                 </a:solidFill>
-                <a:latin typeface="Segoe UI"/>
+                <a:latin typeface="Calibri"/>
               </a:rPr>
               <a:t>▪  </a:t>
             </a:r>
@@ -8015,7 +8200,7 @@
                 <a:solidFill>
                   <a:srgbClr val="26251F"/>
                 </a:solidFill>
-                <a:latin typeface="Segoe UI"/>
+                <a:latin typeface="Calibri"/>
               </a:rPr>
               <a:t>Borrowed from group testing: find a few defectives with far fewer pooled tests than testing everyone.</a:t>
             </a:r>
@@ -8052,9 +8237,9 @@
             <a:r>
               <a:rPr sz="800" b="0" i="1">
                 <a:solidFill>
-                  <a:srgbClr val="2A78D6"/>
-                </a:solidFill>
-                <a:latin typeface="Segoe UI"/>
+                  <a:srgbClr val="26251F"/>
+                </a:solidFill>
+                <a:latin typeface="Calibri"/>
               </a:rPr>
               <a:t>[1] M. Xhemrishi, J. Östman, A. Wachter-Zeh, and A. Graell i Amat, "FedGT: Identification of malicious clients in federated learning with secure aggregation," IEEE Trans. Inf. Forensics Security, vol. 20, pp. 2577–2592, 2025.</a:t>
             </a:r>
@@ -8089,9 +8274,9 @@
                 <a:solidFill>
                   <a:srgbClr val="898781"/>
                 </a:solidFill>
-                <a:latin typeface="Segoe UI"/>
-              </a:rPr>
-              <a:t>3 / 22</a:t>
+                <a:latin typeface="Calibri"/>
+              </a:rPr>
+              <a:t>3 / 23</a:t>
             </a:r>
           </a:p>
         </p:txBody>
@@ -8141,7 +8326,7 @@
                 <a:solidFill>
                   <a:srgbClr val="0B0B0B"/>
                 </a:solidFill>
-                <a:latin typeface="Segoe UI"/>
+                <a:latin typeface="Calibri"/>
               </a:rPr>
               <a:t>Methodology (Base Paper)</a:t>
             </a:r>
@@ -8180,7 +8365,7 @@
                 <a:solidFill>
                   <a:srgbClr val="2A78D6"/>
                 </a:solidFill>
-                <a:latin typeface="Segoe UI"/>
+                <a:latin typeface="Calibri"/>
               </a:rPr>
               <a:t>▪  </a:t>
             </a:r>
@@ -8189,7 +8374,7 @@
                 <a:solidFill>
                   <a:srgbClr val="26251F"/>
                 </a:solidFill>
-                <a:latin typeface="Segoe UI"/>
+                <a:latin typeface="Calibri"/>
               </a:rPr>
               <a:t>An assignment matrix groups n clients into m overlapping groups (the parity-check structure of a code).</a:t>
             </a:r>
@@ -8205,7 +8390,7 @@
                 <a:solidFill>
                   <a:srgbClr val="2A78D6"/>
                 </a:solidFill>
-                <a:latin typeface="Segoe UI"/>
+                <a:latin typeface="Calibri"/>
               </a:rPr>
               <a:t>▪  </a:t>
             </a:r>
@@ -8214,7 +8399,7 @@
                 <a:solidFill>
                   <a:srgbClr val="26251F"/>
                 </a:solidFill>
-                <a:latin typeface="Segoe UI"/>
+                <a:latin typeface="Calibri"/>
               </a:rPr>
               <a:t>Each group is securely aggregated; a test on the group aggregate is positive if any member is malicious.</a:t>
             </a:r>
@@ -8230,7 +8415,7 @@
                 <a:solidFill>
                   <a:srgbClr val="2A78D6"/>
                 </a:solidFill>
-                <a:latin typeface="Segoe UI"/>
+                <a:latin typeface="Calibri"/>
               </a:rPr>
               <a:t>▪  </a:t>
             </a:r>
@@ -8239,7 +8424,7 @@
                 <a:solidFill>
                   <a:srgbClr val="26251F"/>
                 </a:solidFill>
-                <a:latin typeface="Segoe UI"/>
+                <a:latin typeface="Calibri"/>
               </a:rPr>
               <a:t>A COMP / Neyman-Pearson decoder infers which clients are malicious from the group test results.</a:t>
             </a:r>
@@ -8255,7 +8440,7 @@
                 <a:solidFill>
                   <a:srgbClr val="2A78D6"/>
                 </a:solidFill>
-                <a:latin typeface="Segoe UI"/>
+                <a:latin typeface="Calibri"/>
               </a:rPr>
               <a:t>▪  </a:t>
             </a:r>
@@ -8264,7 +8449,7 @@
                 <a:solidFill>
                   <a:srgbClr val="26251F"/>
                 </a:solidFill>
-                <a:latin typeface="Segoe UI"/>
+                <a:latin typeface="Calibri"/>
               </a:rPr>
               <a:t>Flagged clients are excluded; the remaining clean clients are aggregated into the global model.</a:t>
             </a:r>
@@ -8301,9 +8486,9 @@
             <a:r>
               <a:rPr sz="800" b="0" i="1">
                 <a:solidFill>
-                  <a:srgbClr val="2A78D6"/>
-                </a:solidFill>
-                <a:latin typeface="Segoe UI"/>
+                  <a:srgbClr val="26251F"/>
+                </a:solidFill>
+                <a:latin typeface="Calibri"/>
               </a:rPr>
               <a:t>[1] M. Xhemrishi, J. Östman, A. Wachter-Zeh, and A. Graell i Amat, "FedGT: Identification of malicious clients in federated learning with secure aggregation," IEEE Trans. Inf. Forensics Security, vol. 20, pp. 2577–2592, 2025.</a:t>
             </a:r>
@@ -8338,9 +8523,9 @@
                 <a:solidFill>
                   <a:srgbClr val="898781"/>
                 </a:solidFill>
-                <a:latin typeface="Segoe UI"/>
-              </a:rPr>
-              <a:t>4 / 22</a:t>
+                <a:latin typeface="Calibri"/>
+              </a:rPr>
+              <a:t>4 / 23</a:t>
             </a:r>
           </a:p>
         </p:txBody>
@@ -8390,7 +8575,7 @@
                 <a:solidFill>
                   <a:srgbClr val="0B0B0B"/>
                 </a:solidFill>
-                <a:latin typeface="Segoe UI"/>
+                <a:latin typeface="Calibri"/>
               </a:rPr>
               <a:t>Limitations</a:t>
             </a:r>
@@ -8429,7 +8614,7 @@
                 <a:solidFill>
                   <a:srgbClr val="2A78D6"/>
                 </a:solidFill>
-                <a:latin typeface="Segoe UI"/>
+                <a:latin typeface="Calibri"/>
               </a:rPr>
               <a:t>▪  </a:t>
             </a:r>
@@ -8438,7 +8623,7 @@
                 <a:solidFill>
                   <a:srgbClr val="26251F"/>
                 </a:solidFill>
-                <a:latin typeface="Segoe UI"/>
+                <a:latin typeface="Calibri"/>
               </a:rPr>
               <a:t>Crypto: it treats secure aggregation as a black box, with </a:t>
             </a:r>
@@ -8447,7 +8632,7 @@
                 <a:solidFill>
                   <a:srgbClr val="0B0B0B"/>
                 </a:solidFill>
-                <a:latin typeface="Segoe UI"/>
+                <a:latin typeface="Calibri"/>
               </a:rPr>
               <a:t>no post-quantum layer</a:t>
             </a:r>
@@ -8456,7 +8641,7 @@
                 <a:solidFill>
                   <a:srgbClr val="26251F"/>
                 </a:solidFill>
-                <a:latin typeface="Segoe UI"/>
+                <a:latin typeface="Calibri"/>
               </a:rPr>
               <a:t>, in a lattice-only field.</a:t>
             </a:r>
@@ -8472,7 +8657,7 @@
                 <a:solidFill>
                   <a:srgbClr val="2A78D6"/>
                 </a:solidFill>
-                <a:latin typeface="Segoe UI"/>
+                <a:latin typeface="Calibri"/>
               </a:rPr>
               <a:t>▪  </a:t>
             </a:r>
@@ -8481,7 +8666,7 @@
                 <a:solidFill>
                   <a:srgbClr val="26251F"/>
                 </a:solidFill>
-                <a:latin typeface="Segoe UI"/>
+                <a:latin typeface="Calibri"/>
               </a:rPr>
               <a:t>Cost: it needs a </a:t>
             </a:r>
@@ -8490,7 +8675,7 @@
                 <a:solidFill>
                   <a:srgbClr val="0B0B0B"/>
                 </a:solidFill>
-                <a:latin typeface="Segoe UI"/>
+                <a:latin typeface="Calibri"/>
               </a:rPr>
               <a:t>server validation set</a:t>
             </a:r>
@@ -8499,7 +8684,7 @@
                 <a:solidFill>
                   <a:srgbClr val="26251F"/>
                 </a:solidFill>
-                <a:latin typeface="Segoe UI"/>
+                <a:latin typeface="Calibri"/>
               </a:rPr>
               <a:t> and per-round group testing over fixed overlapping groups.</a:t>
             </a:r>
@@ -8515,7 +8700,7 @@
                 <a:solidFill>
                   <a:srgbClr val="2A78D6"/>
                 </a:solidFill>
-                <a:latin typeface="Segoe UI"/>
+                <a:latin typeface="Calibri"/>
               </a:rPr>
               <a:t>▪  </a:t>
             </a:r>
@@ -8524,7 +8709,7 @@
                 <a:solidFill>
                   <a:srgbClr val="26251F"/>
                 </a:solidFill>
-                <a:latin typeface="Segoe UI"/>
+                <a:latin typeface="Calibri"/>
               </a:rPr>
               <a:t>Single-round decode: it identifies attackers from </a:t>
             </a:r>
@@ -8533,7 +8718,7 @@
                 <a:solidFill>
                   <a:srgbClr val="0B0B0B"/>
                 </a:solidFill>
-                <a:latin typeface="Segoe UI"/>
+                <a:latin typeface="Calibri"/>
               </a:rPr>
               <a:t>one round's tests</a:t>
             </a:r>
@@ -8542,7 +8727,7 @@
                 <a:solidFill>
                   <a:srgbClr val="26251F"/>
                 </a:solidFill>
-                <a:latin typeface="Segoe UI"/>
+                <a:latin typeface="Calibri"/>
               </a:rPr>
               <a:t>, using no information across rounds.</a:t>
             </a:r>
@@ -8558,7 +8743,7 @@
                 <a:solidFill>
                   <a:srgbClr val="2A78D6"/>
                 </a:solidFill>
-                <a:latin typeface="Segoe UI"/>
+                <a:latin typeface="Calibri"/>
               </a:rPr>
               <a:t>▪  </a:t>
             </a:r>
@@ -8567,7 +8752,7 @@
                 <a:solidFill>
                   <a:srgbClr val="26251F"/>
                 </a:solidFill>
-                <a:latin typeface="Segoe UI"/>
+                <a:latin typeface="Calibri"/>
               </a:rPr>
               <a:t>Unexplained failure: it does not characterize </a:t>
             </a:r>
@@ -8576,7 +8761,7 @@
                 <a:solidFill>
                   <a:srgbClr val="0B0B0B"/>
                 </a:solidFill>
-                <a:latin typeface="Segoe UI"/>
+                <a:latin typeface="Calibri"/>
               </a:rPr>
               <a:t>why ordinary robust aggregation breaks</a:t>
             </a:r>
@@ -8585,7 +8770,7 @@
                 <a:solidFill>
                   <a:srgbClr val="26251F"/>
                 </a:solidFill>
-                <a:latin typeface="Segoe UI"/>
+                <a:latin typeface="Calibri"/>
               </a:rPr>
               <a:t> once updates are hidden.</a:t>
             </a:r>
@@ -8622,9 +8807,9 @@
             <a:r>
               <a:rPr sz="800" b="0" i="1">
                 <a:solidFill>
-                  <a:srgbClr val="2A78D6"/>
-                </a:solidFill>
-                <a:latin typeface="Segoe UI"/>
+                  <a:srgbClr val="26251F"/>
+                </a:solidFill>
+                <a:latin typeface="Calibri"/>
               </a:rPr>
               <a:t>[1] M. Xhemrishi, J. Östman, A. Wachter-Zeh, and A. Graell i Amat, "FedGT: Identification of malicious clients in federated learning with secure aggregation," IEEE Trans. Inf. Forensics Security, vol. 20, pp. 2577–2592, 2025.</a:t>
             </a:r>
@@ -8659,9 +8844,9 @@
                 <a:solidFill>
                   <a:srgbClr val="898781"/>
                 </a:solidFill>
-                <a:latin typeface="Segoe UI"/>
-              </a:rPr>
-              <a:t>5 / 22</a:t>
+                <a:latin typeface="Calibri"/>
+              </a:rPr>
+              <a:t>5 / 23</a:t>
             </a:r>
           </a:p>
         </p:txBody>
@@ -8711,7 +8896,7 @@
                 <a:solidFill>
                   <a:srgbClr val="0B0B0B"/>
                 </a:solidFill>
-                <a:latin typeface="Segoe UI"/>
+                <a:latin typeface="Calibri"/>
               </a:rPr>
               <a:t>Paper Selection</a:t>
             </a:r>
@@ -8750,7 +8935,7 @@
                 <a:solidFill>
                   <a:srgbClr val="2A78D6"/>
                 </a:solidFill>
-                <a:latin typeface="Segoe UI"/>
+                <a:latin typeface="Calibri"/>
               </a:rPr>
               <a:t>▪  </a:t>
             </a:r>
@@ -8759,7 +8944,7 @@
                 <a:solidFill>
                   <a:srgbClr val="26251F"/>
                 </a:solidFill>
-                <a:latin typeface="Segoe UI"/>
+                <a:latin typeface="Calibri"/>
               </a:rPr>
               <a:t>Venue quality: IEEE TIFS, a Q1 security journal. Recency: published 2025.</a:t>
             </a:r>
@@ -8775,7 +8960,7 @@
                 <a:solidFill>
                   <a:srgbClr val="2A78D6"/>
                 </a:solidFill>
-                <a:latin typeface="Segoe UI"/>
+                <a:latin typeface="Calibri"/>
               </a:rPr>
               <a:t>▪  </a:t>
             </a:r>
@@ -8784,7 +8969,7 @@
                 <a:solidFill>
                   <a:srgbClr val="26251F"/>
                 </a:solidFill>
-                <a:latin typeface="Segoe UI"/>
+                <a:latin typeface="Calibri"/>
               </a:rPr>
               <a:t>Relevance: it solves our exact sub-problem, malicious-client identification under secure aggregation.</a:t>
             </a:r>
@@ -8800,7 +8985,7 @@
                 <a:solidFill>
                   <a:srgbClr val="2A78D6"/>
                 </a:solidFill>
-                <a:latin typeface="Segoe UI"/>
+                <a:latin typeface="Calibri"/>
               </a:rPr>
               <a:t>▪  </a:t>
             </a:r>
@@ -8809,7 +8994,7 @@
                 <a:solidFill>
                   <a:srgbClr val="26251F"/>
                 </a:solidFill>
-                <a:latin typeface="Segoe UI"/>
+                <a:latin typeface="Calibri"/>
               </a:rPr>
               <a:t>Method strength: its group testing outperforms the geometric median (RFA) and Multi-Krum in its own study.</a:t>
             </a:r>
@@ -8825,7 +9010,7 @@
                 <a:solidFill>
                   <a:srgbClr val="2A78D6"/>
                 </a:solidFill>
-                <a:latin typeface="Segoe UI"/>
+                <a:latin typeface="Calibri"/>
               </a:rPr>
               <a:t>▪  </a:t>
             </a:r>
@@ -8834,7 +9019,7 @@
                 <a:solidFill>
                   <a:srgbClr val="26251F"/>
                 </a:solidFill>
-                <a:latin typeface="Segoe UI"/>
+                <a:latin typeface="Calibri"/>
               </a:rPr>
               <a:t>Reproducible: public code and a clearly specified protocol, a solid foundation to build on.</a:t>
             </a:r>
@@ -8871,9 +9056,9 @@
             <a:r>
               <a:rPr sz="800" b="0" i="1">
                 <a:solidFill>
-                  <a:srgbClr val="2A78D6"/>
-                </a:solidFill>
-                <a:latin typeface="Segoe UI"/>
+                  <a:srgbClr val="26251F"/>
+                </a:solidFill>
+                <a:latin typeface="Calibri"/>
               </a:rPr>
               <a:t>[1] M. Xhemrishi, J. Östman, A. Wachter-Zeh, and A. Graell i Amat, "FedGT: Identification of malicious clients in federated learning with secure aggregation," IEEE Trans. Inf. Forensics Security, vol. 20, pp. 2577–2592, 2025.</a:t>
             </a:r>
@@ -8887,9 +9072,9 @@
             <a:r>
               <a:rPr sz="800" b="0" i="1">
                 <a:solidFill>
-                  <a:srgbClr val="2A78D6"/>
-                </a:solidFill>
-                <a:latin typeface="Segoe UI"/>
+                  <a:srgbClr val="26251F"/>
+                </a:solidFill>
+                <a:latin typeface="Calibri"/>
               </a:rPr>
               <a:t>[8] K. Pillutla, S. M. Kakade, and Z. Harchaoui, "Robust aggregation for federated learning," IEEE Trans. Signal Process., vol. 70, pp. 1142–1154, 2022.</a:t>
             </a:r>
@@ -8924,9 +9109,9 @@
                 <a:solidFill>
                   <a:srgbClr val="898781"/>
                 </a:solidFill>
-                <a:latin typeface="Segoe UI"/>
-              </a:rPr>
-              <a:t>6 / 22</a:t>
+                <a:latin typeface="Calibri"/>
+              </a:rPr>
+              <a:t>6 / 23</a:t>
             </a:r>
           </a:p>
         </p:txBody>
@@ -8976,7 +9161,7 @@
                 <a:solidFill>
                   <a:srgbClr val="0B0B0B"/>
                 </a:solidFill>
-                <a:latin typeface="Segoe UI"/>
+                <a:latin typeface="Calibri"/>
               </a:rPr>
               <a:t>Proposed Method</a:t>
             </a:r>
@@ -9010,7 +9195,7 @@
                 <a:solidFill>
                   <a:srgbClr val="26251F"/>
                 </a:solidFill>
-                <a:latin typeface="Segoe UI"/>
+                <a:latin typeface="Calibri"/>
               </a:rPr>
               <a:t>One framework that is private, post-quantum, and Byzantine-robust at the same time.</a:t>
             </a:r>
@@ -9049,7 +9234,7 @@
                 <a:solidFill>
                   <a:srgbClr val="2A78D6"/>
                 </a:solidFill>
-                <a:latin typeface="Segoe UI"/>
+                <a:latin typeface="Calibri"/>
               </a:rPr>
               <a:t>▪  </a:t>
             </a:r>
@@ -9058,7 +9243,7 @@
                 <a:solidFill>
                   <a:srgbClr val="26251F"/>
                 </a:solidFill>
-                <a:latin typeface="Segoe UI"/>
+                <a:latin typeface="Calibri"/>
               </a:rPr>
               <a:t>Hide updates within clusters using a code-based (HQC) masking protocol: the server sees only cluster sums.</a:t>
             </a:r>
@@ -9074,7 +9259,7 @@
                 <a:solidFill>
                   <a:srgbClr val="2A78D6"/>
                 </a:solidFill>
-                <a:latin typeface="Segoe UI"/>
+                <a:latin typeface="Calibri"/>
               </a:rPr>
               <a:t>▪  </a:t>
             </a:r>
@@ -9083,7 +9268,7 @@
                 <a:solidFill>
                   <a:srgbClr val="26251F"/>
                 </a:solidFill>
-                <a:latin typeface="Segoe UI"/>
+                <a:latin typeface="Calibri"/>
               </a:rPr>
               <a:t>Run group testing across re-randomized clusters over rounds to identify attackers (CB-SAFE+).</a:t>
             </a:r>
@@ -9099,7 +9284,7 @@
                 <a:solidFill>
                   <a:srgbClr val="2A78D6"/>
                 </a:solidFill>
-                <a:latin typeface="Segoe UI"/>
+                <a:latin typeface="Calibri"/>
               </a:rPr>
               <a:t>▪  </a:t>
             </a:r>
@@ -9108,7 +9293,7 @@
                 <a:solidFill>
                   <a:srgbClr val="26251F"/>
                 </a:solidFill>
-                <a:latin typeface="Segoe UI"/>
+                <a:latin typeface="Calibri"/>
               </a:rPr>
               <a:t>Confidentiality lives below the cluster boundary; robustness operates above it; post-quantum by construction.</a:t>
             </a:r>
@@ -9145,9 +9330,9 @@
             <a:r>
               <a:rPr sz="800" b="0" i="1">
                 <a:solidFill>
-                  <a:srgbClr val="2A78D6"/>
-                </a:solidFill>
-                <a:latin typeface="Segoe UI"/>
+                  <a:srgbClr val="26251F"/>
+                </a:solidFill>
+                <a:latin typeface="Calibri"/>
               </a:rPr>
               <a:t>[1] M. Xhemrishi, J. Östman, A. Wachter-Zeh, and A. Graell i Amat, "FedGT: Identification of malicious clients in federated learning with secure aggregation," IEEE Trans. Inf. Forensics Security, vol. 20, pp. 2577–2592, 2025.</a:t>
             </a:r>
@@ -9161,9 +9346,9 @@
             <a:r>
               <a:rPr sz="800" b="0" i="1">
                 <a:solidFill>
-                  <a:srgbClr val="2A78D6"/>
-                </a:solidFill>
-                <a:latin typeface="Segoe UI"/>
+                  <a:srgbClr val="26251F"/>
+                </a:solidFill>
+                <a:latin typeface="Calibri"/>
               </a:rPr>
               <a:t>[2] K. Bonawitz, V. Ivanov, B. Kreuter, A. Marcedone, H. B. McMahan, S. Patel, D. Ramage, A. Segal, and K. Seth, "Practical secure aggregation for privacy-preserving machine learning," in Proc. ACM CCS, 2017, pp. 1175–1191.</a:t>
             </a:r>
@@ -9198,9 +9383,9 @@
                 <a:solidFill>
                   <a:srgbClr val="898781"/>
                 </a:solidFill>
-                <a:latin typeface="Segoe UI"/>
-              </a:rPr>
-              <a:t>7 / 22</a:t>
+                <a:latin typeface="Calibri"/>
+              </a:rPr>
+              <a:t>7 / 23</a:t>
             </a:r>
           </a:p>
         </p:txBody>
@@ -9250,7 +9435,7 @@
                 <a:solidFill>
                   <a:srgbClr val="0B0B0B"/>
                 </a:solidFill>
-                <a:latin typeface="Segoe UI"/>
+                <a:latin typeface="Calibri"/>
               </a:rPr>
               <a:t>Methodology (Ours): Masking</a:t>
             </a:r>
@@ -9289,7 +9474,7 @@
                 <a:solidFill>
                   <a:srgbClr val="2A78D6"/>
                 </a:solidFill>
-                <a:latin typeface="Segoe UI"/>
+                <a:latin typeface="Calibri"/>
               </a:rPr>
               <a:t>▪  </a:t>
             </a:r>
@@ -9298,7 +9483,7 @@
                 <a:solidFill>
                   <a:srgbClr val="26251F"/>
                 </a:solidFill>
-                <a:latin typeface="Segoe UI"/>
+                <a:latin typeface="Calibri"/>
               </a:rPr>
               <a:t>We adopt Bonawitz-style double masking: pairwise masks cancel in the cluster sum, so individuals stay hidden.</a:t>
             </a:r>
@@ -9314,7 +9499,7 @@
                 <a:solidFill>
                   <a:srgbClr val="2A78D6"/>
                 </a:solidFill>
-                <a:latin typeface="Segoe UI"/>
+                <a:latin typeface="Calibri"/>
               </a:rPr>
               <a:t>▪  </a:t>
             </a:r>
@@ -9323,7 +9508,7 @@
                 <a:solidFill>
                   <a:srgbClr val="26251F"/>
                 </a:solidFill>
-                <a:latin typeface="Segoe UI"/>
+                <a:latin typeface="Calibri"/>
               </a:rPr>
               <a:t>Dropout resilience via Shamir secret sharing of the self-masks.</a:t>
             </a:r>
@@ -9339,7 +9524,7 @@
                 <a:solidFill>
                   <a:srgbClr val="2A78D6"/>
                 </a:solidFill>
-                <a:latin typeface="Segoe UI"/>
+                <a:latin typeface="Calibri"/>
               </a:rPr>
               <a:t>▪  </a:t>
             </a:r>
@@ -9348,7 +9533,7 @@
                 <a:solidFill>
                   <a:srgbClr val="26251F"/>
                 </a:solidFill>
-                <a:latin typeface="Segoe UI"/>
+                <a:latin typeface="Calibri"/>
               </a:rPr>
               <a:t>Our change: masks are seeded from a KEM, so per-round traffic carries no cryptographic bytes at all.</a:t>
             </a:r>
@@ -9409,9 +9594,9 @@
             <a:r>
               <a:rPr sz="800" b="0" i="1">
                 <a:solidFill>
-                  <a:srgbClr val="2A78D6"/>
-                </a:solidFill>
-                <a:latin typeface="Segoe UI"/>
+                  <a:srgbClr val="26251F"/>
+                </a:solidFill>
+                <a:latin typeface="Calibri"/>
               </a:rPr>
               <a:t>[2] K. Bonawitz, V. Ivanov, B. Kreuter, A. Marcedone, H. B. McMahan, S. Patel, D. Ramage, A. Segal, and K. Seth, "Practical secure aggregation for privacy-preserving machine learning," in Proc. ACM CCS, 2017, pp. 1175–1191.</a:t>
             </a:r>
@@ -9446,9 +9631,9 @@
                 <a:solidFill>
                   <a:srgbClr val="898781"/>
                 </a:solidFill>
-                <a:latin typeface="Segoe UI"/>
-              </a:rPr>
-              <a:t>8 / 22</a:t>
+                <a:latin typeface="Calibri"/>
+              </a:rPr>
+              <a:t>8 / 23</a:t>
             </a:r>
           </a:p>
         </p:txBody>

</xml_diff>

<commit_message>
Deck: add in-text [n] citation markers on every slide that carries a reference
Each cited source now appears as a bracketed [n] within a sentence on its slide,
matching the full-form reference in that slide's footnote (verified per-slide).

Co-Authored-By: Claude Opus 4.8 <noreply@anthropic.com>
</commit_message>
<xml_diff>
--- a/paper/cbsafe_deck.pptx
+++ b/paper/cbsafe_deck.pptx
@@ -3377,7 +3377,7 @@
                 </a:solidFill>
                 <a:latin typeface="Calibri"/>
               </a:rPr>
-              <a:t>We adopt the core idea: identify malicious clients from group-level observations, never from individual updates.</a:t>
+              <a:t>We adopt the core idea from FedGT [1]: identify malicious clients from group-level observations, never from individual updates.</a:t>
             </a:r>
           </a:p>
           <a:p>
@@ -3601,7 +3601,7 @@
                 </a:solidFill>
                 <a:latin typeface="Calibri"/>
               </a:rPr>
-              <a:t>We adopt HQC, the code-based KEM NIST selected in 2025, for post-quantum confidentiality.</a:t>
+              <a:t>We adopt HQC, the code-based KEM NIST selected in 2025 [3], for post-quantum confidentiality.</a:t>
             </a:r>
           </a:p>
           <a:p>
@@ -3651,7 +3651,7 @@
                 </a:solidFill>
                 <a:latin typeface="Calibri"/>
               </a:rPr>
-              <a:t>Our change: HQC sits behind a KEM-agnostic interface, so ML-KEM swaps in with one configuration line.</a:t>
+              <a:t>Our change: HQC sits behind a KEM-agnostic interface, so ML-KEM [9] swaps in with one configuration line.</a:t>
             </a:r>
           </a:p>
         </p:txBody>
@@ -4008,6 +4008,22 @@
               <a:t>[2] K. Bonawitz, V. Ivanov, B. Kreuter, A. Marcedone, H. B. McMahan, S. Patel, D. Ramage, A. Segal, and K. Seth, "Practical secure aggregation for privacy-preserving machine learning," in Proc. ACM CCS, 2017, pp. 1175–1191.</a:t>
             </a:r>
           </a:p>
+          <a:p>
+            <a:pPr>
+              <a:spcAft>
+                <a:spcPts val="100"/>
+              </a:spcAft>
+            </a:pPr>
+            <a:r>
+              <a:rPr sz="800" b="0" i="1">
+                <a:solidFill>
+                  <a:srgbClr val="26251F"/>
+                </a:solidFill>
+                <a:latin typeface="Calibri"/>
+              </a:rPr>
+              <a:t>[3] National Institute of Standards and Technology, "Status report on the fourth round of the NIST post-quantum cryptography standardization process," NIST IR 8545, Mar. 2025.</a:t>
+            </a:r>
+          </a:p>
         </p:txBody>
       </p:sp>
       <p:sp>
@@ -4140,7 +4156,7 @@
                 </a:solidFill>
                 <a:latin typeface="Calibri"/>
               </a:rPr>
-              <a:t>Crypto: FedGT is crypto-agnostic → </a:t>
+              <a:t>Crypto: FedGT [1] is crypto-agnostic → </a:t>
             </a:r>
             <a:r>
               <a:rPr sz="1500" b="1" i="0">
@@ -4571,7 +4587,7 @@
                 </a:solidFill>
                 <a:latin typeface="Calibri"/>
               </a:rPr>
-              <a:t> over re-randomized clusters with a root-loss probe: identifies attackers the server never sees.</a:t>
+              <a:t> over re-randomized clusters (extending FedGT [1]) with a root-loss probe [5]: identifies attackers the server never sees.</a:t>
             </a:r>
           </a:p>
           <a:p>
@@ -4828,7 +4844,7 @@
                 </a:solidFill>
                 <a:latin typeface="Calibri"/>
               </a:rPr>
-              <a:t>Venue and recency: the basis paper is Q1 (IEEE TIFS), 2025; supporting sources are top-tier (ACM CCS, NIST).</a:t>
+              <a:t>Venue and recency: the basis paper [1] is Q1 (IEEE TIFS), 2025; supporting sources are top-tier (ACM CCS [2], NIST [3]).</a:t>
             </a:r>
           </a:p>
           <a:p>
@@ -5410,7 +5426,7 @@
                 </a:solidFill>
                 <a:latin typeface="Calibri"/>
               </a:rPr>
-              <a:t>One training round: confidentiality within clusters, temporal group testing over re-randomized clusters, robust aggregation.</a:t>
+              <a:t>One training round: confidentiality within clusters [2], temporal group testing over re-randomized clusters [1], robust aggregation.</a:t>
             </a:r>
           </a:p>
         </p:txBody>
@@ -5674,7 +5690,7 @@
                 </a:solidFill>
                 <a:latin typeface="Calibri"/>
               </a:rPr>
-              <a:t>Attacks: sign-flip (laundering), label-flip, backdoor. Baselines: mean, trimmed, median, Krum, Bulyan, RFA, FLTrust, FedGT.</a:t>
+              <a:t>Attacks: sign-flip (laundering), label-flip, backdoor. Baselines: mean, trimmed, median [6], Krum, Bulyan, RFA, FLTrust, FedGT [1].</a:t>
             </a:r>
           </a:p>
         </p:txBody>
@@ -5922,7 +5938,7 @@
                 </a:solidFill>
                 <a:latin typeface="Calibri"/>
               </a:rPr>
-              <a:t>Under sign-flip at f ≥ 0.2 every coordinate-wise rule collapses to chance; CB-SAFE+ holds and ties FedGT.</a:t>
+              <a:t>Under sign-flip at f ≥ 0.2 every coordinate-wise rule collapses to chance; CB-SAFE+ holds and ties FedGT [1].</a:t>
             </a:r>
           </a:p>
         </p:txBody>
@@ -6163,7 +6179,7 @@
                 </a:solidFill>
                 <a:latin typeface="Calibri"/>
               </a:rPr>
-              <a:t>Secure aggregation hides updates behind masks, but its key exchange </a:t>
+              <a:t>Secure aggregation [2] hides updates behind masks, but its key exchange </a:t>
             </a:r>
             <a:r>
               <a:rPr sz="1500" b="1" i="0">
@@ -6427,7 +6443,7 @@
                 </a:solidFill>
                 <a:latin typeface="Calibri"/>
               </a:rPr>
-              <a:t>Test accuracy vs. round for eight rules, over three datasets (rows) and three malicious fractions (columns); CB-SAFE+ tracks the clean baseline while the others diverge (from the paper, Fig. 7).</a:t>
+              <a:t>Test accuracy vs. round for eight rules including FedGT [1], over three datasets (rows) and three malicious fractions (columns); CB-SAFE+ tracks the clean baseline while the others diverge (from the paper, Fig. 7).</a:t>
             </a:r>
           </a:p>
         </p:txBody>
@@ -6659,7 +6675,7 @@
                 </a:solidFill>
                 <a:latin typeface="Calibri"/>
               </a:rPr>
-              <a:t>Malicious and honest suspicion separate within a few rounds; attackers are named from group-level observations alone.</a:t>
+              <a:t>Malicious and honest suspicion separate within a few rounds; attackers are named from group-level observations alone, following the group-testing idea of FedGT [1].</a:t>
             </a:r>
           </a:p>
         </p:txBody>
@@ -6843,7 +6859,7 @@
                 </a:solidFill>
                 <a:latin typeface="Calibri"/>
               </a:rPr>
-              <a:t>Label-flip test accuracy (from the paper, Table VI); CB-SAFE+ matches FedGT and leads at the hardest setting (f=0.3).</a:t>
+              <a:t>Label-flip test accuracy (from the paper, Table VI); CB-SAFE+ matches FedGT [1] and leads at the hardest setting (f=0.3).</a:t>
             </a:r>
           </a:p>
         </p:txBody>
@@ -7123,7 +7139,7 @@
                 </a:solidFill>
                 <a:latin typeface="Calibri"/>
               </a:rPr>
-              <a:t>Code-based (HQC) confidentiality gives crypto diversity beyond lattices; ML-KEM swaps in unchanged.</a:t>
+              <a:t>Code-based (HQC [3]) confidentiality gives crypto diversity beyond lattices; ML-KEM [9] swaps in unchanged.</a:t>
             </a:r>
           </a:p>
           <a:p>
@@ -7362,7 +7378,7 @@
                 </a:solidFill>
                 <a:latin typeface="Calibri"/>
               </a:rPr>
-              <a:t>CB-SAFE unifies code-based PQ secure aggregation with temporal group-testing robustness in one protocol.</a:t>
+              <a:t>CB-SAFE unifies code-based PQ secure aggregation [2], [3] with temporal group-testing robustness [1] in one protocol.</a:t>
             </a:r>
           </a:p>
           <a:p>
@@ -7887,7 +7903,7 @@
                 </a:solidFill>
                 <a:latin typeface="Calibri"/>
               </a:rPr>
-              <a:t>Quantum threat: Shor's algorithm breaks classical key exchange, and traffic recorded today is decryptable later.</a:t>
+              <a:t>Quantum threat: Shor's algorithm [4] breaks classical key exchange, and traffic recorded today is decryptable later.</a:t>
             </a:r>
           </a:p>
           <a:p>
@@ -7912,7 +7928,7 @@
                 </a:solidFill>
                 <a:latin typeface="Calibri"/>
               </a:rPr>
-              <a:t>Crypto diversity: NIST selected the code-based KEM HQC in 2025 to hedge a lattice break; that diversity has not reached FL.</a:t>
+              <a:t>Crypto diversity: NIST selected the code-based KEM HQC in 2025 [3] to hedge a lattice break; that diversity has not reached FL.</a:t>
             </a:r>
           </a:p>
           <a:p>
@@ -8127,7 +8143,7 @@
                 </a:solidFill>
                 <a:latin typeface="Calibri"/>
               </a:rPr>
-              <a:t>FedGT (IEEE TIFS, 2025) is the closest peer to our robustness mechanism.</a:t>
+              <a:t>FedGT [1] (IEEE TIFS, 2025) is the closest peer to our robustness mechanism.</a:t>
             </a:r>
           </a:p>
           <a:p>
@@ -8376,7 +8392,7 @@
                 </a:solidFill>
                 <a:latin typeface="Calibri"/>
               </a:rPr>
-              <a:t>An assignment matrix groups n clients into m overlapping groups (the parity-check structure of a code).</a:t>
+              <a:t>In FedGT [1], an assignment matrix groups n clients into m overlapping groups (the parity-check structure of a code).</a:t>
             </a:r>
           </a:p>
           <a:p>
@@ -8625,7 +8641,7 @@
                 </a:solidFill>
                 <a:latin typeface="Calibri"/>
               </a:rPr>
-              <a:t>Crypto: it treats secure aggregation as a black box, with </a:t>
+              <a:t>Crypto: FedGT [1] treats secure aggregation as a black box, with </a:t>
             </a:r>
             <a:r>
               <a:rPr sz="1500" b="1" i="0">
@@ -8946,7 +8962,7 @@
                 </a:solidFill>
                 <a:latin typeface="Calibri"/>
               </a:rPr>
-              <a:t>Venue quality: IEEE TIFS, a Q1 security journal. Recency: published 2025.</a:t>
+              <a:t>Venue quality: FedGT [1] is in IEEE TIFS, a Q1 security journal. Recency: published 2025.</a:t>
             </a:r>
           </a:p>
           <a:p>
@@ -8996,7 +9012,7 @@
                 </a:solidFill>
                 <a:latin typeface="Calibri"/>
               </a:rPr>
-              <a:t>Method strength: its group testing outperforms the geometric median (RFA) and Multi-Krum in its own study.</a:t>
+              <a:t>Method strength: its group testing outperforms the geometric median (RFA) [8] and Multi-Krum in its own study.</a:t>
             </a:r>
           </a:p>
           <a:p>
@@ -9245,7 +9261,7 @@
                 </a:solidFill>
                 <a:latin typeface="Calibri"/>
               </a:rPr>
-              <a:t>Hide updates within clusters using a code-based (HQC) masking protocol: the server sees only cluster sums.</a:t>
+              <a:t>Hide updates within clusters using a code-based (HQC) masking protocol [2]: the server sees only cluster sums.</a:t>
             </a:r>
           </a:p>
           <a:p>
@@ -9270,7 +9286,7 @@
                 </a:solidFill>
                 <a:latin typeface="Calibri"/>
               </a:rPr>
-              <a:t>Run group testing across re-randomized clusters over rounds to identify attackers (CB-SAFE+).</a:t>
+              <a:t>Run group testing [1] across re-randomized clusters over rounds to identify attackers (CB-SAFE+).</a:t>
             </a:r>
           </a:p>
           <a:p>
@@ -9485,7 +9501,7 @@
                 </a:solidFill>
                 <a:latin typeface="Calibri"/>
               </a:rPr>
-              <a:t>We adopt Bonawitz-style double masking: pairwise masks cancel in the cluster sum, so individuals stay hidden.</a:t>
+              <a:t>We adopt Bonawitz-style double masking [2]: pairwise masks cancel in the cluster sum, so individuals stay hidden.</a:t>
             </a:r>
           </a:p>
           <a:p>

</xml_diff>

<commit_message>
EMNIST sign-flip: add seeds 1-2 for CB-SAFE+ and FedGT; report 3-seed mean+/-std
- Ran real seeds 1,2 (new Dirichlet partitions) for CB-SAFE+ (hybrid) and FedGT on
  EMNIST sign-flip. Table V EMNIST cells for these two now show mean+/-std.
- Honest result: tie at f=0.1/0.2 (overlapping bars); CB-SAFE+ wins at f=0.3
  (85.4+/-0.2 vs 84.2+/-0.1, non-overlapping) -- the edge holds across all 3 seeds.
- Recompiled paper, re-cropped Table V into the deck (full four-dataset width).

Co-Authored-By: Claude Opus 4.8 <noreply@anthropic.com>
</commit_message>
<xml_diff>
--- a/paper/cbsafe_deck.pptx
+++ b/paper/cbsafe_deck.pptx
@@ -5892,8 +5892,8 @@
         </p:blipFill>
         <p:spPr>
           <a:xfrm>
-            <a:off x="979890" y="2468880"/>
-            <a:ext cx="10231913" cy="3154680"/>
+            <a:off x="1081726" y="2468880"/>
+            <a:ext cx="10028242" cy="3154680"/>
           </a:xfrm>
           <a:prstGeom prst="rect">
             <a:avLst/>

</xml_diff>

<commit_message>
Add scalability (cost-vs-N) + new 6-panel architecture; EMNIST label-flip 3-seed
- Replace architecture figure with the new 6-panel (a-f) drawio diagram.
- New scalability result: per-client cost is O(1) in N (cluster c=3) vs O(N) for
  all-pairs SecAgg -- 500x less setup traffic at N=1000. Adds plot_scaling.py,
  fig_scaling_cost, a "Scalability" paper subsection, and a deck slide.
- EMNIST label-flip now 3-seed for CB-SAFE+ and FedGT (Table VI): honest tie
  (f=.1/.2), slim CB-SAFE+ edge at f=.3. Caption updated.
- run_scale.py: client-population sweep runner (N=100/500/1000), sweep in progress.

Co-Authored-By: Claude Opus 4.8 <noreply@anthropic.com>
</commit_message>
<xml_diff>
--- a/paper/cbsafe_deck.pptx
+++ b/paper/cbsafe_deck.pptx
@@ -30,6 +30,7 @@
     <p:sldId id="278" r:id="rId29"/>
     <p:sldId id="279" r:id="rId30"/>
     <p:sldId id="280" r:id="rId31"/>
+    <p:sldId id="281" r:id="rId32"/>
   </p:sldIdLst>
   <p:sldSz cx="12191695" cy="6858000" type="screen4x3"/>
   <p:notesSz cx="6858000" cy="9144000"/>
@@ -3350,8 +3351,8 @@
         </p:blipFill>
         <p:spPr>
           <a:xfrm>
-            <a:off x="2278856" y="2286000"/>
-            <a:ext cx="7633982" cy="3520440"/>
+            <a:off x="3141632" y="1828800"/>
+            <a:ext cx="5908429" cy="3977639"/>
           </a:xfrm>
           <a:prstGeom prst="rect">
             <a:avLst/>
@@ -3443,7 +3444,7 @@
                 </a:solidFill>
                 <a:latin typeface="Calibri"/>
               </a:rPr>
-              <a:t>9 / 23</a:t>
+              <a:t>9 / 24</a:t>
             </a:r>
           </a:p>
         </p:txBody>
@@ -3691,7 +3692,7 @@
                 </a:solidFill>
                 <a:latin typeface="Calibri"/>
               </a:rPr>
-              <a:t>10 / 23</a:t>
+              <a:t>10 / 24</a:t>
             </a:r>
           </a:p>
         </p:txBody>
@@ -3915,7 +3916,7 @@
                 </a:solidFill>
                 <a:latin typeface="Calibri"/>
               </a:rPr>
-              <a:t>11 / 23</a:t>
+              <a:t>11 / 24</a:t>
             </a:r>
           </a:p>
         </p:txBody>
@@ -4155,7 +4156,7 @@
                 </a:solidFill>
                 <a:latin typeface="Calibri"/>
               </a:rPr>
-              <a:t>12 / 23</a:t>
+              <a:t>12 / 24</a:t>
             </a:r>
           </a:p>
         </p:txBody>
@@ -4470,7 +4471,7 @@
                 </a:solidFill>
                 <a:latin typeface="Calibri"/>
               </a:rPr>
-              <a:t>13 / 23</a:t>
+              <a:t>13 / 24</a:t>
             </a:r>
           </a:p>
         </p:txBody>
@@ -4815,7 +4816,7 @@
                 </a:solidFill>
                 <a:latin typeface="Calibri"/>
               </a:rPr>
-              <a:t>14 / 23</a:t>
+              <a:t>14 / 24</a:t>
             </a:r>
           </a:p>
         </p:txBody>
@@ -5158,7 +5159,7 @@
                 </a:solidFill>
                 <a:latin typeface="Calibri"/>
               </a:rPr>
-              <a:t>15 / 23</a:t>
+              <a:t>15 / 24</a:t>
             </a:r>
           </a:p>
         </p:txBody>
@@ -5473,7 +5474,7 @@
                 </a:solidFill>
                 <a:latin typeface="Calibri"/>
               </a:rPr>
-              <a:t>16 / 23</a:t>
+              <a:t>16 / 24</a:t>
             </a:r>
           </a:p>
         </p:txBody>
@@ -5737,7 +5738,7 @@
                 </a:solidFill>
                 <a:latin typeface="Calibri"/>
               </a:rPr>
-              <a:t>17 / 23</a:t>
+              <a:t>17 / 24</a:t>
             </a:r>
           </a:p>
         </p:txBody>
@@ -5892,8 +5893,8 @@
         </p:blipFill>
         <p:spPr>
           <a:xfrm>
-            <a:off x="1081726" y="2468880"/>
-            <a:ext cx="10028242" cy="3154680"/>
+            <a:off x="1021059" y="2468880"/>
+            <a:ext cx="10149576" cy="3154680"/>
           </a:xfrm>
           <a:prstGeom prst="rect">
             <a:avLst/>
@@ -5969,7 +5970,7 @@
                 </a:solidFill>
                 <a:latin typeface="Calibri"/>
               </a:rPr>
-              <a:t>18 / 23</a:t>
+              <a:t>18 / 24</a:t>
             </a:r>
           </a:p>
         </p:txBody>
@@ -6290,7 +6291,7 @@
                 </a:solidFill>
                 <a:latin typeface="Calibri"/>
               </a:rPr>
-              <a:t>1 / 23</a:t>
+              <a:t>1 / 24</a:t>
             </a:r>
           </a:p>
         </p:txBody>
@@ -6474,7 +6475,7 @@
                 </a:solidFill>
                 <a:latin typeface="Calibri"/>
               </a:rPr>
-              <a:t>19 / 23</a:t>
+              <a:t>19 / 24</a:t>
             </a:r>
           </a:p>
         </p:txBody>
@@ -6706,7 +6707,7 @@
                 </a:solidFill>
                 <a:latin typeface="Calibri"/>
               </a:rPr>
-              <a:t>20 / 23</a:t>
+              <a:t>20 / 24</a:t>
             </a:r>
           </a:p>
         </p:txBody>
@@ -6861,8 +6862,8 @@
         </p:blipFill>
         <p:spPr>
           <a:xfrm>
-            <a:off x="1225977" y="2468880"/>
-            <a:ext cx="9739740" cy="3108960"/>
+            <a:off x="1450206" y="2468880"/>
+            <a:ext cx="9291281" cy="3108960"/>
           </a:xfrm>
           <a:prstGeom prst="rect">
             <a:avLst/>
@@ -6938,7 +6939,7 @@
                 </a:solidFill>
                 <a:latin typeface="Calibri"/>
               </a:rPr>
-              <a:t>21 / 23</a:t>
+              <a:t>21 / 24</a:t>
             </a:r>
           </a:p>
         </p:txBody>
@@ -7211,7 +7212,7 @@
                 </a:solidFill>
                 <a:latin typeface="Calibri"/>
               </a:rPr>
-              <a:t>22 / 23</a:t>
+              <a:t>22 / 24</a:t>
             </a:r>
           </a:p>
         </p:txBody>
@@ -7263,7 +7264,7 @@
                 </a:solidFill>
                 <a:latin typeface="Calibri"/>
               </a:rPr>
-              <a:t>Conclusion</a:t>
+              <a:t>Results: Scalability</a:t>
             </a:r>
           </a:p>
         </p:txBody>
@@ -7277,6 +7278,40 @@
         <p:spPr>
           <a:xfrm>
             <a:off x="685800" y="1417320"/>
+            <a:ext cx="10881360" cy="548640"/>
+          </a:xfrm>
+          <a:prstGeom prst="rect">
+            <a:avLst/>
+          </a:prstGeom>
+          <a:noFill/>
+        </p:spPr>
+        <p:txBody>
+          <a:bodyPr wrap="square">
+            <a:spAutoFit/>
+          </a:bodyPr>
+          <a:lstStyle/>
+          <a:p>
+            <a:r>
+              <a:rPr sz="1600" b="0" i="1">
+                <a:solidFill>
+                  <a:srgbClr val="26251F"/>
+                </a:solidFill>
+                <a:latin typeface="Calibri"/>
+              </a:rPr>
+              <a:t>Per-client cost vs client population (from the paper).</a:t>
+            </a:r>
+          </a:p>
+        </p:txBody>
+      </p:sp>
+      <p:sp>
+        <p:nvSpPr>
+          <p:cNvPr id="4" name="TextBox 3"/>
+          <p:cNvSpPr txBox="1"/>
+          <p:nvPr/>
+        </p:nvSpPr>
+        <p:spPr>
+          <a:xfrm>
+            <a:off x="685800" y="1947672"/>
             <a:ext cx="10881360" cy="4023360"/>
           </a:xfrm>
           <a:prstGeom prst="rect">
@@ -7311,7 +7346,7 @@
                 </a:solidFill>
                 <a:latin typeface="Calibri"/>
               </a:rPr>
-              <a:t>CB-SAFE unifies code-based PQ secure aggregation [2], [3] with temporal group-testing robustness [1] in one protocol.</a:t>
+              <a:t>CB-SAFE masks only within clusters of c=3, so each client keeps c−1 partners: per-client cost is flat in N, unlike all-pairs secure aggregation [2] which grows O(N).</a:t>
             </a:r>
           </a:p>
           <a:p>
@@ -7336,64 +7371,38 @@
                 </a:solidFill>
                 <a:latin typeface="Calibri"/>
               </a:rPr>
-              <a:t>It ties the state of the art (FedGT [1]) on robustness and detection, at lower cost, and adds crypto diversity plus a failure theory.</a:t>
-            </a:r>
-          </a:p>
-          <a:p>
-            <a:pPr>
-              <a:spcAft>
-                <a:spcPts val="900"/>
-              </a:spcAft>
-            </a:pPr>
-            <a:r>
-              <a:rPr sz="1800">
-                <a:solidFill>
-                  <a:srgbClr val="2A78D6"/>
-                </a:solidFill>
-                <a:latin typeface="Calibri"/>
-              </a:rPr>
-              <a:t>▪  </a:t>
-            </a:r>
-            <a:r>
-              <a:rPr sz="1800" b="0" i="0">
-                <a:solidFill>
-                  <a:srgbClr val="26251F"/>
-                </a:solidFill>
-                <a:latin typeface="Calibri"/>
-              </a:rPr>
-              <a:t>Limitations: update authentication is out of the code-based scope; EMNIST detection uses a single seed.</a:t>
-            </a:r>
-          </a:p>
-          <a:p>
-            <a:pPr>
-              <a:spcAft>
-                <a:spcPts val="900"/>
-              </a:spcAft>
-            </a:pPr>
-            <a:r>
-              <a:rPr sz="1800">
-                <a:solidFill>
-                  <a:srgbClr val="2A78D6"/>
-                </a:solidFill>
-                <a:latin typeface="Calibri"/>
-              </a:rPr>
-              <a:t>▪  </a:t>
-            </a:r>
-            <a:r>
-              <a:rPr sz="1800" b="0" i="0">
-                <a:solidFill>
-                  <a:srgbClr val="26251F"/>
-                </a:solidFill>
-                <a:latin typeface="Calibri"/>
-              </a:rPr>
-              <a:t>Future work: code-based signatures for authentication, larger client populations, and adaptive attackers.</a:t>
-            </a:r>
-          </a:p>
-        </p:txBody>
-      </p:sp>
-      <p:sp>
-        <p:nvSpPr>
-          <p:cNvPr id="4" name="TextBox 3"/>
+              <a:t>At N=1000, one-time setup is 15.2 KiB (HQC) vs 7.4 MiB for all-pairs — a 500× reduction; the privacy law (1−f)^c and the laundering bound are per-cluster, so guarantees are N-independent.</a:t>
+            </a:r>
+          </a:p>
+        </p:txBody>
+      </p:sp>
+      <p:pic>
+        <p:nvPicPr>
+          <p:cNvPr id="5" name="Picture 4" descr="fig_scaling_cost.png"/>
+          <p:cNvPicPr>
+            <a:picLocks noChangeAspect="1"/>
+          </p:cNvPicPr>
+          <p:nvPr/>
+        </p:nvPicPr>
+        <p:blipFill>
+          <a:blip r:embed="rId2"/>
+          <a:stretch>
+            <a:fillRect/>
+          </a:stretch>
+        </p:blipFill>
+        <p:spPr>
+          <a:xfrm>
+            <a:off x="2553474" y="3246120"/>
+            <a:ext cx="7084745" cy="2514600"/>
+          </a:xfrm>
+          <a:prstGeom prst="rect">
+            <a:avLst/>
+          </a:prstGeom>
+        </p:spPr>
+      </p:pic>
+      <p:sp>
+        <p:nvSpPr>
+          <p:cNvPr id="6" name="TextBox 5"/>
           <p:cNvSpPr txBox="1"/>
           <p:nvPr/>
         </p:nvSpPr>
@@ -7425,46 +7434,14 @@
                 </a:solidFill>
                 <a:latin typeface="Calibri"/>
               </a:rPr>
-              <a:t>[1] M. Xhemrishi, J. Östman, A. Wachter-Zeh, and A. Graell i Amat, "FedGT: Identification of malicious clients in federated learning with secure aggregation," IEEE Trans. Inf. Forensics Security, vol. 20, pp. 2577–2592, 2025.</a:t>
-            </a:r>
-          </a:p>
-          <a:p>
-            <a:pPr>
-              <a:spcAft>
-                <a:spcPts val="100"/>
-              </a:spcAft>
-            </a:pPr>
-            <a:r>
-              <a:rPr sz="900" b="0" i="1">
-                <a:solidFill>
-                  <a:srgbClr val="26251F"/>
-                </a:solidFill>
-                <a:latin typeface="Calibri"/>
-              </a:rPr>
               <a:t>[2] K. Bonawitz, V. Ivanov, B. Kreuter, A. Marcedone, H. B. McMahan, S. Patel, D. Ramage, A. Segal, and K. Seth, "Practical secure aggregation for privacy-preserving machine learning," in Proc. ACM CCS, 2017, pp. 1175–1191.</a:t>
             </a:r>
           </a:p>
-          <a:p>
-            <a:pPr>
-              <a:spcAft>
-                <a:spcPts val="100"/>
-              </a:spcAft>
-            </a:pPr>
-            <a:r>
-              <a:rPr sz="900" b="0" i="1">
-                <a:solidFill>
-                  <a:srgbClr val="26251F"/>
-                </a:solidFill>
-                <a:latin typeface="Calibri"/>
-              </a:rPr>
-              <a:t>[3] National Institute of Standards and Technology, "Status report on the fourth round of the NIST post-quantum cryptography standardization process," NIST IR 8545, Mar. 2025.</a:t>
-            </a:r>
-          </a:p>
-        </p:txBody>
-      </p:sp>
-      <p:sp>
-        <p:nvSpPr>
-          <p:cNvPr id="5" name="TextBox 4"/>
+        </p:txBody>
+      </p:sp>
+      <p:sp>
+        <p:nvSpPr>
+          <p:cNvPr id="7" name="TextBox 6"/>
           <p:cNvSpPr txBox="1"/>
           <p:nvPr/>
         </p:nvSpPr>
@@ -7492,7 +7469,7 @@
                 </a:solidFill>
                 <a:latin typeface="Calibri"/>
               </a:rPr>
-              <a:t>23 / 23</a:t>
+              <a:t>23 / 24</a:t>
             </a:r>
           </a:p>
         </p:txBody>
@@ -7544,6 +7521,287 @@
                 </a:solidFill>
                 <a:latin typeface="Calibri"/>
               </a:rPr>
+              <a:t>Conclusion</a:t>
+            </a:r>
+          </a:p>
+        </p:txBody>
+      </p:sp>
+      <p:sp>
+        <p:nvSpPr>
+          <p:cNvPr id="3" name="TextBox 2"/>
+          <p:cNvSpPr txBox="1"/>
+          <p:nvPr/>
+        </p:nvSpPr>
+        <p:spPr>
+          <a:xfrm>
+            <a:off x="685800" y="1417320"/>
+            <a:ext cx="10881360" cy="4023360"/>
+          </a:xfrm>
+          <a:prstGeom prst="rect">
+            <a:avLst/>
+          </a:prstGeom>
+          <a:noFill/>
+        </p:spPr>
+        <p:txBody>
+          <a:bodyPr wrap="square">
+            <a:spAutoFit/>
+          </a:bodyPr>
+          <a:lstStyle/>
+          <a:p>
+            <a:pPr>
+              <a:spcAft>
+                <a:spcPts val="900"/>
+              </a:spcAft>
+            </a:pPr>
+            <a:r>
+              <a:rPr sz="1800">
+                <a:solidFill>
+                  <a:srgbClr val="2A78D6"/>
+                </a:solidFill>
+                <a:latin typeface="Calibri"/>
+              </a:rPr>
+              <a:t>▪  </a:t>
+            </a:r>
+            <a:r>
+              <a:rPr sz="1800" b="0" i="0">
+                <a:solidFill>
+                  <a:srgbClr val="26251F"/>
+                </a:solidFill>
+                <a:latin typeface="Calibri"/>
+              </a:rPr>
+              <a:t>CB-SAFE unifies code-based PQ secure aggregation [2], [3] with temporal group-testing robustness [1] in one protocol.</a:t>
+            </a:r>
+          </a:p>
+          <a:p>
+            <a:pPr>
+              <a:spcAft>
+                <a:spcPts val="900"/>
+              </a:spcAft>
+            </a:pPr>
+            <a:r>
+              <a:rPr sz="1800">
+                <a:solidFill>
+                  <a:srgbClr val="2A78D6"/>
+                </a:solidFill>
+                <a:latin typeface="Calibri"/>
+              </a:rPr>
+              <a:t>▪  </a:t>
+            </a:r>
+            <a:r>
+              <a:rPr sz="1800" b="0" i="0">
+                <a:solidFill>
+                  <a:srgbClr val="26251F"/>
+                </a:solidFill>
+                <a:latin typeface="Calibri"/>
+              </a:rPr>
+              <a:t>It ties the state of the art (FedGT [1]) on robustness and detection, at lower cost, and adds crypto diversity plus a failure theory.</a:t>
+            </a:r>
+          </a:p>
+          <a:p>
+            <a:pPr>
+              <a:spcAft>
+                <a:spcPts val="900"/>
+              </a:spcAft>
+            </a:pPr>
+            <a:r>
+              <a:rPr sz="1800">
+                <a:solidFill>
+                  <a:srgbClr val="2A78D6"/>
+                </a:solidFill>
+                <a:latin typeface="Calibri"/>
+              </a:rPr>
+              <a:t>▪  </a:t>
+            </a:r>
+            <a:r>
+              <a:rPr sz="1800" b="0" i="0">
+                <a:solidFill>
+                  <a:srgbClr val="26251F"/>
+                </a:solidFill>
+                <a:latin typeface="Calibri"/>
+              </a:rPr>
+              <a:t>Limitations: update authentication is out of the code-based scope; EMNIST detection uses a single seed.</a:t>
+            </a:r>
+          </a:p>
+          <a:p>
+            <a:pPr>
+              <a:spcAft>
+                <a:spcPts val="900"/>
+              </a:spcAft>
+            </a:pPr>
+            <a:r>
+              <a:rPr sz="1800">
+                <a:solidFill>
+                  <a:srgbClr val="2A78D6"/>
+                </a:solidFill>
+                <a:latin typeface="Calibri"/>
+              </a:rPr>
+              <a:t>▪  </a:t>
+            </a:r>
+            <a:r>
+              <a:rPr sz="1800" b="0" i="0">
+                <a:solidFill>
+                  <a:srgbClr val="26251F"/>
+                </a:solidFill>
+                <a:latin typeface="Calibri"/>
+              </a:rPr>
+              <a:t>Future work: code-based signatures for authentication, larger client populations, and adaptive attackers.</a:t>
+            </a:r>
+          </a:p>
+        </p:txBody>
+      </p:sp>
+      <p:sp>
+        <p:nvSpPr>
+          <p:cNvPr id="4" name="TextBox 3"/>
+          <p:cNvSpPr txBox="1"/>
+          <p:nvPr/>
+        </p:nvSpPr>
+        <p:spPr>
+          <a:xfrm>
+            <a:off x="685800" y="5888736"/>
+            <a:ext cx="10881360" cy="548640"/>
+          </a:xfrm>
+          <a:prstGeom prst="rect">
+            <a:avLst/>
+          </a:prstGeom>
+          <a:noFill/>
+        </p:spPr>
+        <p:txBody>
+          <a:bodyPr wrap="square">
+            <a:spAutoFit/>
+          </a:bodyPr>
+          <a:lstStyle/>
+          <a:p>
+            <a:pPr>
+              <a:spcAft>
+                <a:spcPts val="100"/>
+              </a:spcAft>
+            </a:pPr>
+            <a:r>
+              <a:rPr sz="900" b="0" i="1">
+                <a:solidFill>
+                  <a:srgbClr val="26251F"/>
+                </a:solidFill>
+                <a:latin typeface="Calibri"/>
+              </a:rPr>
+              <a:t>[1] M. Xhemrishi, J. Östman, A. Wachter-Zeh, and A. Graell i Amat, "FedGT: Identification of malicious clients in federated learning with secure aggregation," IEEE Trans. Inf. Forensics Security, vol. 20, pp. 2577–2592, 2025.</a:t>
+            </a:r>
+          </a:p>
+          <a:p>
+            <a:pPr>
+              <a:spcAft>
+                <a:spcPts val="100"/>
+              </a:spcAft>
+            </a:pPr>
+            <a:r>
+              <a:rPr sz="900" b="0" i="1">
+                <a:solidFill>
+                  <a:srgbClr val="26251F"/>
+                </a:solidFill>
+                <a:latin typeface="Calibri"/>
+              </a:rPr>
+              <a:t>[2] K. Bonawitz, V. Ivanov, B. Kreuter, A. Marcedone, H. B. McMahan, S. Patel, D. Ramage, A. Segal, and K. Seth, "Practical secure aggregation for privacy-preserving machine learning," in Proc. ACM CCS, 2017, pp. 1175–1191.</a:t>
+            </a:r>
+          </a:p>
+          <a:p>
+            <a:pPr>
+              <a:spcAft>
+                <a:spcPts val="100"/>
+              </a:spcAft>
+            </a:pPr>
+            <a:r>
+              <a:rPr sz="900" b="0" i="1">
+                <a:solidFill>
+                  <a:srgbClr val="26251F"/>
+                </a:solidFill>
+                <a:latin typeface="Calibri"/>
+              </a:rPr>
+              <a:t>[3] National Institute of Standards and Technology, "Status report on the fourth round of the NIST post-quantum cryptography standardization process," NIST IR 8545, Mar. 2025.</a:t>
+            </a:r>
+          </a:p>
+        </p:txBody>
+      </p:sp>
+      <p:sp>
+        <p:nvSpPr>
+          <p:cNvPr id="5" name="TextBox 4"/>
+          <p:cNvSpPr txBox="1"/>
+          <p:nvPr/>
+        </p:nvSpPr>
+        <p:spPr>
+          <a:xfrm>
+            <a:off x="10927080" y="6419088"/>
+            <a:ext cx="1005840" cy="292608"/>
+          </a:xfrm>
+          <a:prstGeom prst="rect">
+            <a:avLst/>
+          </a:prstGeom>
+          <a:noFill/>
+        </p:spPr>
+        <p:txBody>
+          <a:bodyPr wrap="square">
+            <a:spAutoFit/>
+          </a:bodyPr>
+          <a:lstStyle/>
+          <a:p>
+            <a:pPr algn="r"/>
+            <a:r>
+              <a:rPr sz="1200" b="0" i="0">
+                <a:solidFill>
+                  <a:srgbClr val="898781"/>
+                </a:solidFill>
+                <a:latin typeface="Calibri"/>
+              </a:rPr>
+              <a:t>24 / 24</a:t>
+            </a:r>
+          </a:p>
+        </p:txBody>
+      </p:sp>
+    </p:spTree>
+  </p:cSld>
+  <p:clrMapOvr>
+    <a:masterClrMapping/>
+  </p:clrMapOvr>
+</p:sld>
+</file>
+
+<file path=ppt/slides/slide26.xml><?xml version="1.0" encoding="utf-8"?>
+<p:sld xmlns:a="http://schemas.openxmlformats.org/drawingml/2006/main" xmlns:p="http://schemas.openxmlformats.org/presentationml/2006/main" xmlns:r="http://schemas.openxmlformats.org/officeDocument/2006/relationships">
+  <p:cSld>
+    <p:spTree>
+      <p:nvGrpSpPr>
+        <p:cNvPr id="1" name=""/>
+        <p:cNvGrpSpPr/>
+        <p:nvPr/>
+      </p:nvGrpSpPr>
+      <p:grpSpPr/>
+      <p:sp>
+        <p:nvSpPr>
+          <p:cNvPr id="2" name="TextBox 1"/>
+          <p:cNvSpPr txBox="1"/>
+          <p:nvPr/>
+        </p:nvSpPr>
+        <p:spPr>
+          <a:xfrm>
+            <a:off x="685800" y="384048"/>
+            <a:ext cx="10881360" cy="868680"/>
+          </a:xfrm>
+          <a:prstGeom prst="rect">
+            <a:avLst/>
+          </a:prstGeom>
+          <a:noFill/>
+        </p:spPr>
+        <p:txBody>
+          <a:bodyPr wrap="square">
+            <a:spAutoFit/>
+          </a:bodyPr>
+          <a:lstStyle/>
+          <a:p>
+            <a:r>
+              <a:rPr sz="3400" b="1" i="0">
+                <a:solidFill>
+                  <a:srgbClr val="0B0B0B"/>
+                </a:solidFill>
+                <a:latin typeface="Calibri"/>
+              </a:rPr>
               <a:t>References</a:t>
             </a:r>
           </a:p>
@@ -7976,7 +8234,7 @@
                 </a:solidFill>
                 <a:latin typeface="Calibri"/>
               </a:rPr>
-              <a:t>2 / 23</a:t>
+              <a:t>2 / 24</a:t>
             </a:r>
           </a:p>
         </p:txBody>
@@ -8273,7 +8531,7 @@
                 </a:solidFill>
                 <a:latin typeface="Calibri"/>
               </a:rPr>
-              <a:t>3 / 23</a:t>
+              <a:t>3 / 24</a:t>
             </a:r>
           </a:p>
         </p:txBody>
@@ -8522,7 +8780,7 @@
                 </a:solidFill>
                 <a:latin typeface="Calibri"/>
               </a:rPr>
-              <a:t>4 / 23</a:t>
+              <a:t>4 / 24</a:t>
             </a:r>
           </a:p>
         </p:txBody>
@@ -8771,7 +9029,7 @@
                 </a:solidFill>
                 <a:latin typeface="Calibri"/>
               </a:rPr>
-              <a:t>5 / 23</a:t>
+              <a:t>5 / 24</a:t>
             </a:r>
           </a:p>
         </p:txBody>
@@ -9092,7 +9350,7 @@
                 </a:solidFill>
                 <a:latin typeface="Calibri"/>
               </a:rPr>
-              <a:t>6 / 23</a:t>
+              <a:t>6 / 24</a:t>
             </a:r>
           </a:p>
         </p:txBody>
@@ -9372,7 +9630,7 @@
                 </a:solidFill>
                 <a:latin typeface="Calibri"/>
               </a:rPr>
-              <a:t>7 / 23</a:t>
+              <a:t>7 / 24</a:t>
             </a:r>
           </a:p>
         </p:txBody>
@@ -9646,7 +9904,7 @@
                 </a:solidFill>
                 <a:latin typeface="Calibri"/>
               </a:rPr>
-              <a:t>8 / 23</a:t>
+              <a:t>8 / 24</a:t>
             </a:r>
           </a:p>
         </p:txBody>

</xml_diff>